<commit_message>
Work on documentation for algometry procedures
</commit_message>
<xml_diff>
--- a/assets/images/Experitments_Procedures_Algometry.pptx
+++ b/assets/images/Experitments_Procedures_Algometry.pptx
@@ -5,7 +5,7 @@
     <p:sldMasterId id="2147483684" r:id="rId4"/>
   </p:sldMasterIdLst>
   <p:notesMasterIdLst>
-    <p:notesMasterId r:id="rId20"/>
+    <p:notesMasterId r:id="rId18"/>
   </p:notesMasterIdLst>
   <p:sldIdLst>
     <p:sldId id="256" r:id="rId5"/>
@@ -17,12 +17,10 @@
     <p:sldId id="266" r:id="rId11"/>
     <p:sldId id="268" r:id="rId12"/>
     <p:sldId id="271" r:id="rId13"/>
-    <p:sldId id="259" r:id="rId14"/>
-    <p:sldId id="258" r:id="rId15"/>
-    <p:sldId id="261" r:id="rId16"/>
+    <p:sldId id="258" r:id="rId14"/>
+    <p:sldId id="272" r:id="rId15"/>
+    <p:sldId id="259" r:id="rId16"/>
     <p:sldId id="269" r:id="rId17"/>
-    <p:sldId id="270" r:id="rId18"/>
-    <p:sldId id="272" r:id="rId19"/>
   </p:sldIdLst>
   <p:sldSz cx="21601113" cy="14400213"/>
   <p:notesSz cx="9144000" cy="6858000"/>
@@ -416,7 +414,7 @@
           <a:p>
             <a:fld id="{43466010-90F5-41E6-AAE8-7E580DBF8C7C}" type="datetimeFigureOut">
               <a:rPr lang="en-DK" smtClean="0"/>
-              <a:t>19/04/2026</a:t>
+              <a:t>20/04/2026</a:t>
             </a:fld>
             <a:endParaRPr lang="en-DK"/>
           </a:p>
@@ -816,6 +814,206 @@
           <a:bodyPr/>
           <a:lstStyle/>
           <a:p>
+            <a:r>
+              <a:rPr lang="en-GB" dirty="0"/>
+              <a:t>SR Test</a:t>
+            </a:r>
+            <a:endParaRPr lang="en-DK" dirty="0"/>
+          </a:p>
+        </p:txBody>
+      </p:sp>
+      <p:sp>
+        <p:nvSpPr>
+          <p:cNvPr id="4" name="Slide Number Placeholder 3"/>
+          <p:cNvSpPr>
+            <a:spLocks noGrp="1"/>
+          </p:cNvSpPr>
+          <p:nvPr>
+            <p:ph type="sldNum" sz="quarter" idx="5"/>
+          </p:nvPr>
+        </p:nvSpPr>
+        <p:spPr/>
+        <p:txBody>
+          <a:bodyPr/>
+          <a:lstStyle/>
+          <a:p>
+            <a:fld id="{7F40FA34-EF5F-4A31-AAB0-55E03B625DB3}" type="slidenum">
+              <a:rPr lang="en-DK" smtClean="0"/>
+              <a:t>10</a:t>
+            </a:fld>
+            <a:endParaRPr lang="en-DK"/>
+          </a:p>
+        </p:txBody>
+      </p:sp>
+    </p:spTree>
+    <p:extLst>
+      <p:ext uri="{BB962C8B-B14F-4D97-AF65-F5344CB8AC3E}">
+        <p14:creationId xmlns:p14="http://schemas.microsoft.com/office/powerpoint/2010/main" val="4171509439"/>
+      </p:ext>
+    </p:extLst>
+  </p:cSld>
+  <p:clrMapOvr>
+    <a:masterClrMapping/>
+  </p:clrMapOvr>
+</p:notes>
+</file>
+
+<file path=ppt/notesSlides/notesSlide11.xml><?xml version="1.0" encoding="utf-8"?>
+<p:notes xmlns:a="http://schemas.openxmlformats.org/drawingml/2006/main" xmlns:r="http://schemas.openxmlformats.org/officeDocument/2006/relationships" xmlns:p="http://schemas.openxmlformats.org/presentationml/2006/main">
+  <p:cSld>
+    <p:spTree>
+      <p:nvGrpSpPr>
+        <p:cNvPr id="1" name="">
+          <a:extLst>
+            <a:ext uri="{FF2B5EF4-FFF2-40B4-BE49-F238E27FC236}">
+              <a16:creationId xmlns:a16="http://schemas.microsoft.com/office/drawing/2014/main" id="{4F7BD21B-7D9F-E0F8-219A-52DDCEF8B0AE}"/>
+            </a:ext>
+          </a:extLst>
+        </p:cNvPr>
+        <p:cNvGrpSpPr/>
+        <p:nvPr/>
+      </p:nvGrpSpPr>
+      <p:grpSpPr>
+        <a:xfrm>
+          <a:off x="0" y="0"/>
+          <a:ext cx="0" cy="0"/>
+          <a:chOff x="0" y="0"/>
+          <a:chExt cx="0" cy="0"/>
+        </a:xfrm>
+      </p:grpSpPr>
+      <p:sp>
+        <p:nvSpPr>
+          <p:cNvPr id="2" name="Slide Image Placeholder 1">
+            <a:extLst>
+              <a:ext uri="{FF2B5EF4-FFF2-40B4-BE49-F238E27FC236}">
+                <a16:creationId xmlns:a16="http://schemas.microsoft.com/office/drawing/2014/main" id="{61F3D335-DCE3-4ED7-1C21-A893C155C773}"/>
+              </a:ext>
+            </a:extLst>
+          </p:cNvPr>
+          <p:cNvSpPr>
+            <a:spLocks noGrp="1" noRot="1" noChangeAspect="1"/>
+          </p:cNvSpPr>
+          <p:nvPr>
+            <p:ph type="sldImg"/>
+          </p:nvPr>
+        </p:nvSpPr>
+        <p:spPr/>
+      </p:sp>
+      <p:sp>
+        <p:nvSpPr>
+          <p:cNvPr id="3" name="Notes Placeholder 2">
+            <a:extLst>
+              <a:ext uri="{FF2B5EF4-FFF2-40B4-BE49-F238E27FC236}">
+                <a16:creationId xmlns:a16="http://schemas.microsoft.com/office/drawing/2014/main" id="{00D1E607-816A-862C-33FD-6E0C9CFB3842}"/>
+              </a:ext>
+            </a:extLst>
+          </p:cNvPr>
+          <p:cNvSpPr>
+            <a:spLocks noGrp="1"/>
+          </p:cNvSpPr>
+          <p:nvPr>
+            <p:ph type="body" idx="1"/>
+          </p:nvPr>
+        </p:nvSpPr>
+        <p:spPr/>
+        <p:txBody>
+          <a:bodyPr/>
+          <a:lstStyle/>
+          <a:p>
+            <a:r>
+              <a:rPr lang="en-GB" dirty="0"/>
+              <a:t>CPM Rating: Options for Conditioning stimulation</a:t>
+            </a:r>
+            <a:endParaRPr lang="en-DK" dirty="0"/>
+          </a:p>
+        </p:txBody>
+      </p:sp>
+      <p:sp>
+        <p:nvSpPr>
+          <p:cNvPr id="4" name="Slide Number Placeholder 3">
+            <a:extLst>
+              <a:ext uri="{FF2B5EF4-FFF2-40B4-BE49-F238E27FC236}">
+                <a16:creationId xmlns:a16="http://schemas.microsoft.com/office/drawing/2014/main" id="{6392C377-68BE-BD00-336E-C7E17B47C2FB}"/>
+              </a:ext>
+            </a:extLst>
+          </p:cNvPr>
+          <p:cNvSpPr>
+            <a:spLocks noGrp="1"/>
+          </p:cNvSpPr>
+          <p:nvPr>
+            <p:ph type="sldNum" sz="quarter" idx="5"/>
+          </p:nvPr>
+        </p:nvSpPr>
+        <p:spPr/>
+        <p:txBody>
+          <a:bodyPr/>
+          <a:lstStyle/>
+          <a:p>
+            <a:fld id="{7F40FA34-EF5F-4A31-AAB0-55E03B625DB3}" type="slidenum">
+              <a:rPr lang="en-DK" smtClean="0"/>
+              <a:t>11</a:t>
+            </a:fld>
+            <a:endParaRPr lang="en-DK"/>
+          </a:p>
+        </p:txBody>
+      </p:sp>
+    </p:spTree>
+    <p:extLst>
+      <p:ext uri="{BB962C8B-B14F-4D97-AF65-F5344CB8AC3E}">
+        <p14:creationId xmlns:p14="http://schemas.microsoft.com/office/powerpoint/2010/main" val="1031653855"/>
+      </p:ext>
+    </p:extLst>
+  </p:cSld>
+  <p:clrMapOvr>
+    <a:masterClrMapping/>
+  </p:clrMapOvr>
+</p:notes>
+</file>
+
+<file path=ppt/notesSlides/notesSlide12.xml><?xml version="1.0" encoding="utf-8"?>
+<p:notes xmlns:a="http://schemas.openxmlformats.org/drawingml/2006/main" xmlns:r="http://schemas.openxmlformats.org/officeDocument/2006/relationships" xmlns:p="http://schemas.openxmlformats.org/presentationml/2006/main">
+  <p:cSld>
+    <p:spTree>
+      <p:nvGrpSpPr>
+        <p:cNvPr id="1" name=""/>
+        <p:cNvGrpSpPr/>
+        <p:nvPr/>
+      </p:nvGrpSpPr>
+      <p:grpSpPr>
+        <a:xfrm>
+          <a:off x="0" y="0"/>
+          <a:ext cx="0" cy="0"/>
+          <a:chOff x="0" y="0"/>
+          <a:chExt cx="0" cy="0"/>
+        </a:xfrm>
+      </p:grpSpPr>
+      <p:sp>
+        <p:nvSpPr>
+          <p:cNvPr id="2" name="Slide Image Placeholder 1"/>
+          <p:cNvSpPr>
+            <a:spLocks noGrp="1" noRot="1" noChangeAspect="1"/>
+          </p:cNvSpPr>
+          <p:nvPr>
+            <p:ph type="sldImg"/>
+          </p:nvPr>
+        </p:nvSpPr>
+        <p:spPr/>
+      </p:sp>
+      <p:sp>
+        <p:nvSpPr>
+          <p:cNvPr id="3" name="Notes Placeholder 2"/>
+          <p:cNvSpPr>
+            <a:spLocks noGrp="1"/>
+          </p:cNvSpPr>
+          <p:nvPr>
+            <p:ph type="body" idx="1"/>
+          </p:nvPr>
+        </p:nvSpPr>
+        <p:spPr/>
+        <p:txBody>
+          <a:bodyPr/>
+          <a:lstStyle/>
+          <a:p>
             <a:pPr marL="0" marR="0" lvl="0" indent="0" algn="l" defTabSz="914400" rtl="0" eaLnBrk="1" fontAlgn="auto" latinLnBrk="0" hangingPunct="1">
               <a:lnSpc>
                 <a:spcPct val="100000"/>
@@ -861,7 +1059,7 @@
           <a:p>
             <a:fld id="{7F40FA34-EF5F-4A31-AAB0-55E03B625DB3}" type="slidenum">
               <a:rPr lang="en-DK" smtClean="0"/>
-              <a:t>10</a:t>
+              <a:t>12</a:t>
             </a:fld>
             <a:endParaRPr lang="en-DK"/>
           </a:p>
@@ -871,226 +1069,6 @@
     <p:extLst>
       <p:ext uri="{BB962C8B-B14F-4D97-AF65-F5344CB8AC3E}">
         <p14:creationId xmlns:p14="http://schemas.microsoft.com/office/powerpoint/2010/main" val="2063522820"/>
-      </p:ext>
-    </p:extLst>
-  </p:cSld>
-  <p:clrMapOvr>
-    <a:masterClrMapping/>
-  </p:clrMapOvr>
-</p:notes>
-</file>
-
-<file path=ppt/notesSlides/notesSlide11.xml><?xml version="1.0" encoding="utf-8"?>
-<p:notes xmlns:a="http://schemas.openxmlformats.org/drawingml/2006/main" xmlns:r="http://schemas.openxmlformats.org/officeDocument/2006/relationships" xmlns:p="http://schemas.openxmlformats.org/presentationml/2006/main">
-  <p:cSld>
-    <p:spTree>
-      <p:nvGrpSpPr>
-        <p:cNvPr id="1" name=""/>
-        <p:cNvGrpSpPr/>
-        <p:nvPr/>
-      </p:nvGrpSpPr>
-      <p:grpSpPr>
-        <a:xfrm>
-          <a:off x="0" y="0"/>
-          <a:ext cx="0" cy="0"/>
-          <a:chOff x="0" y="0"/>
-          <a:chExt cx="0" cy="0"/>
-        </a:xfrm>
-      </p:grpSpPr>
-      <p:sp>
-        <p:nvSpPr>
-          <p:cNvPr id="2" name="Slide Image Placeholder 1"/>
-          <p:cNvSpPr>
-            <a:spLocks noGrp="1" noRot="1" noChangeAspect="1"/>
-          </p:cNvSpPr>
-          <p:nvPr>
-            <p:ph type="sldImg"/>
-          </p:nvPr>
-        </p:nvSpPr>
-        <p:spPr/>
-      </p:sp>
-      <p:sp>
-        <p:nvSpPr>
-          <p:cNvPr id="3" name="Notes Placeholder 2"/>
-          <p:cNvSpPr>
-            <a:spLocks noGrp="1"/>
-          </p:cNvSpPr>
-          <p:nvPr>
-            <p:ph type="body" idx="1"/>
-          </p:nvPr>
-        </p:nvSpPr>
-        <p:spPr/>
-        <p:txBody>
-          <a:bodyPr/>
-          <a:lstStyle/>
-          <a:p>
-            <a:r>
-              <a:rPr lang="en-GB" dirty="0"/>
-              <a:t>SR Test</a:t>
-            </a:r>
-            <a:endParaRPr lang="en-DK" dirty="0"/>
-          </a:p>
-        </p:txBody>
-      </p:sp>
-      <p:sp>
-        <p:nvSpPr>
-          <p:cNvPr id="4" name="Slide Number Placeholder 3"/>
-          <p:cNvSpPr>
-            <a:spLocks noGrp="1"/>
-          </p:cNvSpPr>
-          <p:nvPr>
-            <p:ph type="sldNum" sz="quarter" idx="5"/>
-          </p:nvPr>
-        </p:nvSpPr>
-        <p:spPr/>
-        <p:txBody>
-          <a:bodyPr/>
-          <a:lstStyle/>
-          <a:p>
-            <a:fld id="{7F40FA34-EF5F-4A31-AAB0-55E03B625DB3}" type="slidenum">
-              <a:rPr lang="en-DK" smtClean="0"/>
-              <a:t>11</a:t>
-            </a:fld>
-            <a:endParaRPr lang="en-DK"/>
-          </a:p>
-        </p:txBody>
-      </p:sp>
-    </p:spTree>
-    <p:extLst>
-      <p:ext uri="{BB962C8B-B14F-4D97-AF65-F5344CB8AC3E}">
-        <p14:creationId xmlns:p14="http://schemas.microsoft.com/office/powerpoint/2010/main" val="4171509439"/>
-      </p:ext>
-    </p:extLst>
-  </p:cSld>
-  <p:clrMapOvr>
-    <a:masterClrMapping/>
-  </p:clrMapOvr>
-</p:notes>
-</file>
-
-<file path=ppt/notesSlides/notesSlide12.xml><?xml version="1.0" encoding="utf-8"?>
-<p:notes xmlns:a="http://schemas.openxmlformats.org/drawingml/2006/main" xmlns:r="http://schemas.openxmlformats.org/officeDocument/2006/relationships" xmlns:p="http://schemas.openxmlformats.org/presentationml/2006/main">
-  <p:cSld>
-    <p:spTree>
-      <p:nvGrpSpPr>
-        <p:cNvPr id="1" name="">
-          <a:extLst>
-            <a:ext uri="{FF2B5EF4-FFF2-40B4-BE49-F238E27FC236}">
-              <a16:creationId xmlns:a16="http://schemas.microsoft.com/office/drawing/2014/main" id="{CA79E3A6-5275-57A4-7603-317439430613}"/>
-            </a:ext>
-          </a:extLst>
-        </p:cNvPr>
-        <p:cNvGrpSpPr/>
-        <p:nvPr/>
-      </p:nvGrpSpPr>
-      <p:grpSpPr>
-        <a:xfrm>
-          <a:off x="0" y="0"/>
-          <a:ext cx="0" cy="0"/>
-          <a:chOff x="0" y="0"/>
-          <a:chExt cx="0" cy="0"/>
-        </a:xfrm>
-      </p:grpSpPr>
-      <p:sp>
-        <p:nvSpPr>
-          <p:cNvPr id="2" name="Slide Image Placeholder 1">
-            <a:extLst>
-              <a:ext uri="{FF2B5EF4-FFF2-40B4-BE49-F238E27FC236}">
-                <a16:creationId xmlns:a16="http://schemas.microsoft.com/office/drawing/2014/main" id="{1985A40F-800E-DED1-6CC6-BBB5F6723B31}"/>
-              </a:ext>
-            </a:extLst>
-          </p:cNvPr>
-          <p:cNvSpPr>
-            <a:spLocks noGrp="1" noRot="1" noChangeAspect="1"/>
-          </p:cNvSpPr>
-          <p:nvPr>
-            <p:ph type="sldImg"/>
-          </p:nvPr>
-        </p:nvSpPr>
-        <p:spPr/>
-      </p:sp>
-      <p:sp>
-        <p:nvSpPr>
-          <p:cNvPr id="3" name="Notes Placeholder 2">
-            <a:extLst>
-              <a:ext uri="{FF2B5EF4-FFF2-40B4-BE49-F238E27FC236}">
-                <a16:creationId xmlns:a16="http://schemas.microsoft.com/office/drawing/2014/main" id="{A4F1B0BA-0860-FCC6-167D-DF08FD053487}"/>
-              </a:ext>
-            </a:extLst>
-          </p:cNvPr>
-          <p:cNvSpPr>
-            <a:spLocks noGrp="1"/>
-          </p:cNvSpPr>
-          <p:nvPr>
-            <p:ph type="body" idx="1"/>
-          </p:nvPr>
-        </p:nvSpPr>
-        <p:spPr/>
-        <p:txBody>
-          <a:bodyPr/>
-          <a:lstStyle/>
-          <a:p>
-            <a:pPr marL="0" marR="0" lvl="0" indent="0" algn="l" defTabSz="914400" rtl="0" eaLnBrk="1" fontAlgn="auto" latinLnBrk="0" hangingPunct="1">
-              <a:lnSpc>
-                <a:spcPct val="100000"/>
-              </a:lnSpc>
-              <a:spcBef>
-                <a:spcPts val="0"/>
-              </a:spcBef>
-              <a:spcAft>
-                <a:spcPts val="0"/>
-              </a:spcAft>
-              <a:buClrTx/>
-              <a:buSzTx/>
-              <a:buFontTx/>
-              <a:buNone/>
-              <a:tabLst/>
-              <a:defRPr/>
-            </a:pPr>
-            <a:r>
-              <a:rPr lang="en-GB" dirty="0"/>
-              <a:t>CPM Test</a:t>
-            </a:r>
-            <a:endParaRPr lang="en-DK" dirty="0"/>
-          </a:p>
-          <a:p>
-            <a:endParaRPr lang="en-DK" dirty="0"/>
-          </a:p>
-        </p:txBody>
-      </p:sp>
-      <p:sp>
-        <p:nvSpPr>
-          <p:cNvPr id="4" name="Slide Number Placeholder 3">
-            <a:extLst>
-              <a:ext uri="{FF2B5EF4-FFF2-40B4-BE49-F238E27FC236}">
-                <a16:creationId xmlns:a16="http://schemas.microsoft.com/office/drawing/2014/main" id="{7CBAE594-66C7-675D-D19A-B7AB3907A5E6}"/>
-              </a:ext>
-            </a:extLst>
-          </p:cNvPr>
-          <p:cNvSpPr>
-            <a:spLocks noGrp="1"/>
-          </p:cNvSpPr>
-          <p:nvPr>
-            <p:ph type="sldNum" sz="quarter" idx="5"/>
-          </p:nvPr>
-        </p:nvSpPr>
-        <p:spPr/>
-        <p:txBody>
-          <a:bodyPr/>
-          <a:lstStyle/>
-          <a:p>
-            <a:fld id="{7F40FA34-EF5F-4A31-AAB0-55E03B625DB3}" type="slidenum">
-              <a:rPr lang="en-DK" smtClean="0"/>
-              <a:t>12</a:t>
-            </a:fld>
-            <a:endParaRPr lang="en-DK"/>
-          </a:p>
-        </p:txBody>
-      </p:sp>
-    </p:spTree>
-    <p:extLst>
-      <p:ext uri="{BB962C8B-B14F-4D97-AF65-F5344CB8AC3E}">
-        <p14:creationId xmlns:p14="http://schemas.microsoft.com/office/powerpoint/2010/main" val="3744408952"/>
       </p:ext>
     </p:extLst>
   </p:cSld>
@@ -1203,230 +1181,6 @@
     <p:extLst>
       <p:ext uri="{BB962C8B-B14F-4D97-AF65-F5344CB8AC3E}">
         <p14:creationId xmlns:p14="http://schemas.microsoft.com/office/powerpoint/2010/main" val="858192802"/>
-      </p:ext>
-    </p:extLst>
-  </p:cSld>
-  <p:clrMapOvr>
-    <a:masterClrMapping/>
-  </p:clrMapOvr>
-</p:notes>
-</file>
-
-<file path=ppt/notesSlides/notesSlide14.xml><?xml version="1.0" encoding="utf-8"?>
-<p:notes xmlns:a="http://schemas.openxmlformats.org/drawingml/2006/main" xmlns:r="http://schemas.openxmlformats.org/officeDocument/2006/relationships" xmlns:p="http://schemas.openxmlformats.org/presentationml/2006/main">
-  <p:cSld>
-    <p:spTree>
-      <p:nvGrpSpPr>
-        <p:cNvPr id="1" name="">
-          <a:extLst>
-            <a:ext uri="{FF2B5EF4-FFF2-40B4-BE49-F238E27FC236}">
-              <a16:creationId xmlns:a16="http://schemas.microsoft.com/office/drawing/2014/main" id="{DDB72FAF-C30A-7D8B-BEB5-CBEB6CEAA934}"/>
-            </a:ext>
-          </a:extLst>
-        </p:cNvPr>
-        <p:cNvGrpSpPr/>
-        <p:nvPr/>
-      </p:nvGrpSpPr>
-      <p:grpSpPr>
-        <a:xfrm>
-          <a:off x="0" y="0"/>
-          <a:ext cx="0" cy="0"/>
-          <a:chOff x="0" y="0"/>
-          <a:chExt cx="0" cy="0"/>
-        </a:xfrm>
-      </p:grpSpPr>
-      <p:sp>
-        <p:nvSpPr>
-          <p:cNvPr id="2" name="Slide Image Placeholder 1">
-            <a:extLst>
-              <a:ext uri="{FF2B5EF4-FFF2-40B4-BE49-F238E27FC236}">
-                <a16:creationId xmlns:a16="http://schemas.microsoft.com/office/drawing/2014/main" id="{04D06741-78B7-5340-650E-68D799BAFB7E}"/>
-              </a:ext>
-            </a:extLst>
-          </p:cNvPr>
-          <p:cNvSpPr>
-            <a:spLocks noGrp="1" noRot="1" noChangeAspect="1"/>
-          </p:cNvSpPr>
-          <p:nvPr>
-            <p:ph type="sldImg"/>
-          </p:nvPr>
-        </p:nvSpPr>
-        <p:spPr/>
-      </p:sp>
-      <p:sp>
-        <p:nvSpPr>
-          <p:cNvPr id="3" name="Notes Placeholder 2">
-            <a:extLst>
-              <a:ext uri="{FF2B5EF4-FFF2-40B4-BE49-F238E27FC236}">
-                <a16:creationId xmlns:a16="http://schemas.microsoft.com/office/drawing/2014/main" id="{4C2499CB-A48C-41EB-682F-FE2F9C751A50}"/>
-              </a:ext>
-            </a:extLst>
-          </p:cNvPr>
-          <p:cNvSpPr>
-            <a:spLocks noGrp="1"/>
-          </p:cNvSpPr>
-          <p:nvPr>
-            <p:ph type="body" idx="1"/>
-          </p:nvPr>
-        </p:nvSpPr>
-        <p:spPr/>
-        <p:txBody>
-          <a:bodyPr/>
-          <a:lstStyle/>
-          <a:p>
-            <a:r>
-              <a:rPr lang="en-GB" dirty="0"/>
-              <a:t>Stimulus Rating: Externally Conditioned</a:t>
-            </a:r>
-            <a:endParaRPr lang="en-DK" dirty="0"/>
-          </a:p>
-        </p:txBody>
-      </p:sp>
-      <p:sp>
-        <p:nvSpPr>
-          <p:cNvPr id="4" name="Slide Number Placeholder 3">
-            <a:extLst>
-              <a:ext uri="{FF2B5EF4-FFF2-40B4-BE49-F238E27FC236}">
-                <a16:creationId xmlns:a16="http://schemas.microsoft.com/office/drawing/2014/main" id="{4BE01A3D-E28D-16D7-CDA1-D33B1F88D898}"/>
-              </a:ext>
-            </a:extLst>
-          </p:cNvPr>
-          <p:cNvSpPr>
-            <a:spLocks noGrp="1"/>
-          </p:cNvSpPr>
-          <p:nvPr>
-            <p:ph type="sldNum" sz="quarter" idx="5"/>
-          </p:nvPr>
-        </p:nvSpPr>
-        <p:spPr/>
-        <p:txBody>
-          <a:bodyPr/>
-          <a:lstStyle/>
-          <a:p>
-            <a:fld id="{7F40FA34-EF5F-4A31-AAB0-55E03B625DB3}" type="slidenum">
-              <a:rPr lang="en-DK" smtClean="0"/>
-              <a:t>14</a:t>
-            </a:fld>
-            <a:endParaRPr lang="en-DK"/>
-          </a:p>
-        </p:txBody>
-      </p:sp>
-    </p:spTree>
-    <p:extLst>
-      <p:ext uri="{BB962C8B-B14F-4D97-AF65-F5344CB8AC3E}">
-        <p14:creationId xmlns:p14="http://schemas.microsoft.com/office/powerpoint/2010/main" val="1243729869"/>
-      </p:ext>
-    </p:extLst>
-  </p:cSld>
-  <p:clrMapOvr>
-    <a:masterClrMapping/>
-  </p:clrMapOvr>
-</p:notes>
-</file>
-
-<file path=ppt/notesSlides/notesSlide15.xml><?xml version="1.0" encoding="utf-8"?>
-<p:notes xmlns:a="http://schemas.openxmlformats.org/drawingml/2006/main" xmlns:r="http://schemas.openxmlformats.org/officeDocument/2006/relationships" xmlns:p="http://schemas.openxmlformats.org/presentationml/2006/main">
-  <p:cSld>
-    <p:spTree>
-      <p:nvGrpSpPr>
-        <p:cNvPr id="1" name="">
-          <a:extLst>
-            <a:ext uri="{FF2B5EF4-FFF2-40B4-BE49-F238E27FC236}">
-              <a16:creationId xmlns:a16="http://schemas.microsoft.com/office/drawing/2014/main" id="{4F7BD21B-7D9F-E0F8-219A-52DDCEF8B0AE}"/>
-            </a:ext>
-          </a:extLst>
-        </p:cNvPr>
-        <p:cNvGrpSpPr/>
-        <p:nvPr/>
-      </p:nvGrpSpPr>
-      <p:grpSpPr>
-        <a:xfrm>
-          <a:off x="0" y="0"/>
-          <a:ext cx="0" cy="0"/>
-          <a:chOff x="0" y="0"/>
-          <a:chExt cx="0" cy="0"/>
-        </a:xfrm>
-      </p:grpSpPr>
-      <p:sp>
-        <p:nvSpPr>
-          <p:cNvPr id="2" name="Slide Image Placeholder 1">
-            <a:extLst>
-              <a:ext uri="{FF2B5EF4-FFF2-40B4-BE49-F238E27FC236}">
-                <a16:creationId xmlns:a16="http://schemas.microsoft.com/office/drawing/2014/main" id="{61F3D335-DCE3-4ED7-1C21-A893C155C773}"/>
-              </a:ext>
-            </a:extLst>
-          </p:cNvPr>
-          <p:cNvSpPr>
-            <a:spLocks noGrp="1" noRot="1" noChangeAspect="1"/>
-          </p:cNvSpPr>
-          <p:nvPr>
-            <p:ph type="sldImg"/>
-          </p:nvPr>
-        </p:nvSpPr>
-        <p:spPr/>
-      </p:sp>
-      <p:sp>
-        <p:nvSpPr>
-          <p:cNvPr id="3" name="Notes Placeholder 2">
-            <a:extLst>
-              <a:ext uri="{FF2B5EF4-FFF2-40B4-BE49-F238E27FC236}">
-                <a16:creationId xmlns:a16="http://schemas.microsoft.com/office/drawing/2014/main" id="{00D1E607-816A-862C-33FD-6E0C9CFB3842}"/>
-              </a:ext>
-            </a:extLst>
-          </p:cNvPr>
-          <p:cNvSpPr>
-            <a:spLocks noGrp="1"/>
-          </p:cNvSpPr>
-          <p:nvPr>
-            <p:ph type="body" idx="1"/>
-          </p:nvPr>
-        </p:nvSpPr>
-        <p:spPr/>
-        <p:txBody>
-          <a:bodyPr/>
-          <a:lstStyle/>
-          <a:p>
-            <a:r>
-              <a:rPr lang="en-GB" dirty="0"/>
-              <a:t>CPM Rating: Options for Conditioning stimulation</a:t>
-            </a:r>
-            <a:endParaRPr lang="en-DK" dirty="0"/>
-          </a:p>
-        </p:txBody>
-      </p:sp>
-      <p:sp>
-        <p:nvSpPr>
-          <p:cNvPr id="4" name="Slide Number Placeholder 3">
-            <a:extLst>
-              <a:ext uri="{FF2B5EF4-FFF2-40B4-BE49-F238E27FC236}">
-                <a16:creationId xmlns:a16="http://schemas.microsoft.com/office/drawing/2014/main" id="{6392C377-68BE-BD00-336E-C7E17B47C2FB}"/>
-              </a:ext>
-            </a:extLst>
-          </p:cNvPr>
-          <p:cNvSpPr>
-            <a:spLocks noGrp="1"/>
-          </p:cNvSpPr>
-          <p:nvPr>
-            <p:ph type="sldNum" sz="quarter" idx="5"/>
-          </p:nvPr>
-        </p:nvSpPr>
-        <p:spPr/>
-        <p:txBody>
-          <a:bodyPr/>
-          <a:lstStyle/>
-          <a:p>
-            <a:fld id="{7F40FA34-EF5F-4A31-AAB0-55E03B625DB3}" type="slidenum">
-              <a:rPr lang="en-DK" smtClean="0"/>
-              <a:t>15</a:t>
-            </a:fld>
-            <a:endParaRPr lang="en-DK"/>
-          </a:p>
-        </p:txBody>
-      </p:sp>
-    </p:spTree>
-    <p:extLst>
-      <p:ext uri="{BB962C8B-B14F-4D97-AF65-F5344CB8AC3E}">
-        <p14:creationId xmlns:p14="http://schemas.microsoft.com/office/powerpoint/2010/main" val="1031653855"/>
       </p:ext>
     </p:extLst>
   </p:cSld>
@@ -2419,7 +2173,7 @@
           <a:p>
             <a:fld id="{F1465E3F-0B9F-47C9-9E08-5C827E095B3E}" type="datetimeFigureOut">
               <a:rPr lang="en-DK" smtClean="0"/>
-              <a:t>19/04/2026</a:t>
+              <a:t>20/04/2026</a:t>
             </a:fld>
             <a:endParaRPr lang="en-DK"/>
           </a:p>
@@ -2589,7 +2343,7 @@
           <a:p>
             <a:fld id="{F1465E3F-0B9F-47C9-9E08-5C827E095B3E}" type="datetimeFigureOut">
               <a:rPr lang="en-DK" smtClean="0"/>
-              <a:t>19/04/2026</a:t>
+              <a:t>20/04/2026</a:t>
             </a:fld>
             <a:endParaRPr lang="en-DK"/>
           </a:p>
@@ -2769,7 +2523,7 @@
           <a:p>
             <a:fld id="{F1465E3F-0B9F-47C9-9E08-5C827E095B3E}" type="datetimeFigureOut">
               <a:rPr lang="en-DK" smtClean="0"/>
-              <a:t>19/04/2026</a:t>
+              <a:t>20/04/2026</a:t>
             </a:fld>
             <a:endParaRPr lang="en-DK"/>
           </a:p>
@@ -2939,7 +2693,7 @@
           <a:p>
             <a:fld id="{F1465E3F-0B9F-47C9-9E08-5C827E095B3E}" type="datetimeFigureOut">
               <a:rPr lang="en-DK" smtClean="0"/>
-              <a:t>19/04/2026</a:t>
+              <a:t>20/04/2026</a:t>
             </a:fld>
             <a:endParaRPr lang="en-DK"/>
           </a:p>
@@ -3185,7 +2939,7 @@
           <a:p>
             <a:fld id="{F1465E3F-0B9F-47C9-9E08-5C827E095B3E}" type="datetimeFigureOut">
               <a:rPr lang="en-DK" smtClean="0"/>
-              <a:t>19/04/2026</a:t>
+              <a:t>20/04/2026</a:t>
             </a:fld>
             <a:endParaRPr lang="en-DK"/>
           </a:p>
@@ -3417,7 +3171,7 @@
           <a:p>
             <a:fld id="{F1465E3F-0B9F-47C9-9E08-5C827E095B3E}" type="datetimeFigureOut">
               <a:rPr lang="en-DK" smtClean="0"/>
-              <a:t>19/04/2026</a:t>
+              <a:t>20/04/2026</a:t>
             </a:fld>
             <a:endParaRPr lang="en-DK"/>
           </a:p>
@@ -3784,7 +3538,7 @@
           <a:p>
             <a:fld id="{F1465E3F-0B9F-47C9-9E08-5C827E095B3E}" type="datetimeFigureOut">
               <a:rPr lang="en-DK" smtClean="0"/>
-              <a:t>19/04/2026</a:t>
+              <a:t>20/04/2026</a:t>
             </a:fld>
             <a:endParaRPr lang="en-DK"/>
           </a:p>
@@ -3902,7 +3656,7 @@
           <a:p>
             <a:fld id="{F1465E3F-0B9F-47C9-9E08-5C827E095B3E}" type="datetimeFigureOut">
               <a:rPr lang="en-DK" smtClean="0"/>
-              <a:t>19/04/2026</a:t>
+              <a:t>20/04/2026</a:t>
             </a:fld>
             <a:endParaRPr lang="en-DK"/>
           </a:p>
@@ -3997,7 +3751,7 @@
           <a:p>
             <a:fld id="{F1465E3F-0B9F-47C9-9E08-5C827E095B3E}" type="datetimeFigureOut">
               <a:rPr lang="en-DK" smtClean="0"/>
-              <a:t>19/04/2026</a:t>
+              <a:t>20/04/2026</a:t>
             </a:fld>
             <a:endParaRPr lang="en-DK"/>
           </a:p>
@@ -4274,7 +4028,7 @@
           <a:p>
             <a:fld id="{F1465E3F-0B9F-47C9-9E08-5C827E095B3E}" type="datetimeFigureOut">
               <a:rPr lang="en-DK" smtClean="0"/>
-              <a:t>19/04/2026</a:t>
+              <a:t>20/04/2026</a:t>
             </a:fld>
             <a:endParaRPr lang="en-DK"/>
           </a:p>
@@ -4531,7 +4285,7 @@
           <a:p>
             <a:fld id="{F1465E3F-0B9F-47C9-9E08-5C827E095B3E}" type="datetimeFigureOut">
               <a:rPr lang="en-DK" smtClean="0"/>
-              <a:t>19/04/2026</a:t>
+              <a:t>20/04/2026</a:t>
             </a:fld>
             <a:endParaRPr lang="en-DK"/>
           </a:p>
@@ -4744,7 +4498,7 @@
           <a:p>
             <a:fld id="{F1465E3F-0B9F-47C9-9E08-5C827E095B3E}" type="datetimeFigureOut">
               <a:rPr lang="en-DK" smtClean="0"/>
-              <a:t>19/04/2026</a:t>
+              <a:t>20/04/2026</a:t>
             </a:fld>
             <a:endParaRPr lang="en-DK"/>
           </a:p>
@@ -6311,10 +6065,10 @@
       </p:grpSpPr>
       <p:pic>
         <p:nvPicPr>
-          <p:cNvPr id="2" name="Picture 1">
-            <a:extLst>
-              <a:ext uri="{FF2B5EF4-FFF2-40B4-BE49-F238E27FC236}">
-                <a16:creationId xmlns:a16="http://schemas.microsoft.com/office/drawing/2014/main" id="{4B2E835F-9788-4A9E-1CB6-286FC6F201AE}"/>
+          <p:cNvPr id="3" name="Picture 2">
+            <a:extLst>
+              <a:ext uri="{FF2B5EF4-FFF2-40B4-BE49-F238E27FC236}">
+                <a16:creationId xmlns:a16="http://schemas.microsoft.com/office/drawing/2014/main" id="{2D567D92-1D7A-4407-7B60-AEBD6C9E3233}"/>
               </a:ext>
             </a:extLst>
           </p:cNvPr>
@@ -6331,7 +6085,7 @@
         </p:blipFill>
         <p:spPr>
           <a:xfrm>
-            <a:off x="2108723" y="4081121"/>
+            <a:off x="2108723" y="1732774"/>
             <a:ext cx="8929594" cy="5377107"/>
           </a:xfrm>
           <a:prstGeom prst="rect">
@@ -6339,170 +6093,12 @@
           </a:prstGeom>
         </p:spPr>
       </p:pic>
-      <p:sp>
-        <p:nvSpPr>
-          <p:cNvPr id="4" name="TextBox 3">
-            <a:extLst>
-              <a:ext uri="{FF2B5EF4-FFF2-40B4-BE49-F238E27FC236}">
-                <a16:creationId xmlns:a16="http://schemas.microsoft.com/office/drawing/2014/main" id="{D3D2F7AB-EDED-9987-110A-93FF9F0EE147}"/>
-              </a:ext>
-            </a:extLst>
-          </p:cNvPr>
-          <p:cNvSpPr txBox="1"/>
-          <p:nvPr/>
-        </p:nvSpPr>
-        <p:spPr>
-          <a:xfrm>
-            <a:off x="2108723" y="3303097"/>
-            <a:ext cx="466794" cy="637547"/>
-          </a:xfrm>
-          <a:prstGeom prst="rect">
-            <a:avLst/>
-          </a:prstGeom>
-          <a:noFill/>
-        </p:spPr>
-        <p:txBody>
-          <a:bodyPr wrap="none" rtlCol="0">
-            <a:spAutoFit/>
-          </a:bodyPr>
-          <a:lstStyle/>
-          <a:p>
-            <a:r>
-              <a:rPr lang="en-GB" sz="3543" b="1" dirty="0"/>
-              <a:t>A</a:t>
-            </a:r>
-            <a:endParaRPr lang="en-DK" sz="3543" b="1" dirty="0"/>
-          </a:p>
-        </p:txBody>
-      </p:sp>
-      <p:sp>
-        <p:nvSpPr>
-          <p:cNvPr id="5" name="TextBox 4">
-            <a:extLst>
-              <a:ext uri="{FF2B5EF4-FFF2-40B4-BE49-F238E27FC236}">
-                <a16:creationId xmlns:a16="http://schemas.microsoft.com/office/drawing/2014/main" id="{ED0A835D-47CB-F121-68C0-87BA17B569C8}"/>
-              </a:ext>
-            </a:extLst>
-          </p:cNvPr>
-          <p:cNvSpPr txBox="1"/>
-          <p:nvPr/>
-        </p:nvSpPr>
-        <p:spPr>
-          <a:xfrm>
-            <a:off x="11038317" y="3303097"/>
-            <a:ext cx="465192" cy="637547"/>
-          </a:xfrm>
-          <a:prstGeom prst="rect">
-            <a:avLst/>
-          </a:prstGeom>
-          <a:noFill/>
-        </p:spPr>
-        <p:txBody>
-          <a:bodyPr wrap="none" rtlCol="0">
-            <a:spAutoFit/>
-          </a:bodyPr>
-          <a:lstStyle/>
-          <a:p>
-            <a:r>
-              <a:rPr lang="en-GB" sz="3543" b="1" dirty="0"/>
-              <a:t>B</a:t>
-            </a:r>
-            <a:endParaRPr lang="en-DK" sz="3543" b="1" dirty="0"/>
-          </a:p>
-        </p:txBody>
-      </p:sp>
-      <p:sp>
-        <p:nvSpPr>
-          <p:cNvPr id="6" name="TextBox 5">
-            <a:extLst>
-              <a:ext uri="{FF2B5EF4-FFF2-40B4-BE49-F238E27FC236}">
-                <a16:creationId xmlns:a16="http://schemas.microsoft.com/office/drawing/2014/main" id="{D99D3844-A449-D85C-73B9-627211D70990}"/>
-              </a:ext>
-            </a:extLst>
-          </p:cNvPr>
-          <p:cNvSpPr txBox="1"/>
-          <p:nvPr/>
-        </p:nvSpPr>
-        <p:spPr>
-          <a:xfrm>
-            <a:off x="2717077" y="9464497"/>
-            <a:ext cx="8083479" cy="528606"/>
-          </a:xfrm>
-          <a:prstGeom prst="rect">
-            <a:avLst/>
-          </a:prstGeom>
-          <a:noFill/>
-        </p:spPr>
-        <p:txBody>
-          <a:bodyPr wrap="square">
-            <a:spAutoFit/>
-          </a:bodyPr>
-          <a:lstStyle/>
-          <a:p>
-            <a:pPr algn="ctr"/>
-            <a:r>
-              <a:rPr lang="en-GB" sz="2835" dirty="0">
-                <a:latin typeface="Courier New" panose="02070309020205020404" pitchFamily="49" charset="0"/>
-                <a:cs typeface="Courier New" panose="02070309020205020404" pitchFamily="49" charset="0"/>
-              </a:rPr>
-              <a:t>stop-mode="stop-on-maximal-rating"</a:t>
-            </a:r>
-            <a:endParaRPr lang="en-DK" sz="2835" dirty="0">
-              <a:latin typeface="Courier New" panose="02070309020205020404" pitchFamily="49" charset="0"/>
-              <a:cs typeface="Courier New" panose="02070309020205020404" pitchFamily="49" charset="0"/>
-            </a:endParaRPr>
-          </a:p>
-        </p:txBody>
-      </p:sp>
-      <p:sp>
-        <p:nvSpPr>
-          <p:cNvPr id="7" name="TextBox 6">
-            <a:extLst>
-              <a:ext uri="{FF2B5EF4-FFF2-40B4-BE49-F238E27FC236}">
-                <a16:creationId xmlns:a16="http://schemas.microsoft.com/office/drawing/2014/main" id="{81EF5B11-9E93-3D8A-846A-829E2895889A}"/>
-              </a:ext>
-            </a:extLst>
-          </p:cNvPr>
-          <p:cNvSpPr txBox="1"/>
-          <p:nvPr/>
-        </p:nvSpPr>
-        <p:spPr>
-          <a:xfrm>
-            <a:off x="11646671" y="9464497"/>
-            <a:ext cx="8321240" cy="528606"/>
-          </a:xfrm>
-          <a:prstGeom prst="rect">
-            <a:avLst/>
-          </a:prstGeom>
-          <a:noFill/>
-        </p:spPr>
-        <p:txBody>
-          <a:bodyPr wrap="square">
-            <a:spAutoFit/>
-          </a:bodyPr>
-          <a:lstStyle/>
-          <a:p>
-            <a:pPr algn="ctr"/>
-            <a:r>
-              <a:rPr lang="en-GB" sz="2835" dirty="0">
-                <a:latin typeface="Courier New" panose="02070309020205020404" pitchFamily="49" charset="0"/>
-                <a:cs typeface="Courier New" panose="02070309020205020404" pitchFamily="49" charset="0"/>
-              </a:rPr>
-              <a:t>stop-mode="stop-when-button-pressed"</a:t>
-            </a:r>
-            <a:endParaRPr lang="en-DK" sz="2835" dirty="0">
-              <a:latin typeface="Courier New" panose="02070309020205020404" pitchFamily="49" charset="0"/>
-              <a:cs typeface="Courier New" panose="02070309020205020404" pitchFamily="49" charset="0"/>
-            </a:endParaRPr>
-          </a:p>
-        </p:txBody>
-      </p:sp>
       <p:pic>
         <p:nvPicPr>
-          <p:cNvPr id="9" name="Picture 8">
-            <a:extLst>
-              <a:ext uri="{FF2B5EF4-FFF2-40B4-BE49-F238E27FC236}">
-                <a16:creationId xmlns:a16="http://schemas.microsoft.com/office/drawing/2014/main" id="{40825D57-0C6A-B345-7828-E6E19D1CE261}"/>
+          <p:cNvPr id="5" name="Picture 4">
+            <a:extLst>
+              <a:ext uri="{FF2B5EF4-FFF2-40B4-BE49-F238E27FC236}">
+                <a16:creationId xmlns:a16="http://schemas.microsoft.com/office/drawing/2014/main" id="{C8AFEC52-3815-9C68-F89C-CAF6C6F3021A}"/>
               </a:ext>
             </a:extLst>
           </p:cNvPr>
@@ -6519,8 +6115,304 @@
         </p:blipFill>
         <p:spPr>
           <a:xfrm>
-            <a:off x="11038317" y="4056650"/>
-            <a:ext cx="8929594" cy="5355017"/>
+            <a:off x="11038317" y="1721807"/>
+            <a:ext cx="8929594" cy="5388074"/>
+          </a:xfrm>
+          <a:prstGeom prst="rect">
+            <a:avLst/>
+          </a:prstGeom>
+        </p:spPr>
+      </p:pic>
+      <p:sp>
+        <p:nvSpPr>
+          <p:cNvPr id="6" name="TextBox 5">
+            <a:extLst>
+              <a:ext uri="{FF2B5EF4-FFF2-40B4-BE49-F238E27FC236}">
+                <a16:creationId xmlns:a16="http://schemas.microsoft.com/office/drawing/2014/main" id="{8A4AC4C8-78E4-C069-9A70-9801603FA761}"/>
+              </a:ext>
+            </a:extLst>
+          </p:cNvPr>
+          <p:cNvSpPr txBox="1"/>
+          <p:nvPr/>
+        </p:nvSpPr>
+        <p:spPr>
+          <a:xfrm>
+            <a:off x="2108723" y="954750"/>
+            <a:ext cx="466794" cy="637547"/>
+          </a:xfrm>
+          <a:prstGeom prst="rect">
+            <a:avLst/>
+          </a:prstGeom>
+          <a:noFill/>
+        </p:spPr>
+        <p:txBody>
+          <a:bodyPr wrap="none" rtlCol="0">
+            <a:spAutoFit/>
+          </a:bodyPr>
+          <a:lstStyle/>
+          <a:p>
+            <a:r>
+              <a:rPr lang="en-GB" sz="3543" b="1" dirty="0"/>
+              <a:t>A</a:t>
+            </a:r>
+            <a:endParaRPr lang="en-DK" sz="3543" b="1" dirty="0"/>
+          </a:p>
+        </p:txBody>
+      </p:sp>
+      <p:sp>
+        <p:nvSpPr>
+          <p:cNvPr id="7" name="TextBox 6">
+            <a:extLst>
+              <a:ext uri="{FF2B5EF4-FFF2-40B4-BE49-F238E27FC236}">
+                <a16:creationId xmlns:a16="http://schemas.microsoft.com/office/drawing/2014/main" id="{13440474-ACFE-8967-E740-AFD0293118CB}"/>
+              </a:ext>
+            </a:extLst>
+          </p:cNvPr>
+          <p:cNvSpPr txBox="1"/>
+          <p:nvPr/>
+        </p:nvSpPr>
+        <p:spPr>
+          <a:xfrm>
+            <a:off x="11038317" y="954750"/>
+            <a:ext cx="465192" cy="637547"/>
+          </a:xfrm>
+          <a:prstGeom prst="rect">
+            <a:avLst/>
+          </a:prstGeom>
+          <a:noFill/>
+        </p:spPr>
+        <p:txBody>
+          <a:bodyPr wrap="none" rtlCol="0">
+            <a:spAutoFit/>
+          </a:bodyPr>
+          <a:lstStyle/>
+          <a:p>
+            <a:r>
+              <a:rPr lang="en-GB" sz="3543" b="1" dirty="0"/>
+              <a:t>B</a:t>
+            </a:r>
+            <a:endParaRPr lang="en-DK" sz="3543" b="1" dirty="0"/>
+          </a:p>
+        </p:txBody>
+      </p:sp>
+      <p:sp>
+        <p:nvSpPr>
+          <p:cNvPr id="2" name="TextBox 1">
+            <a:extLst>
+              <a:ext uri="{FF2B5EF4-FFF2-40B4-BE49-F238E27FC236}">
+                <a16:creationId xmlns:a16="http://schemas.microsoft.com/office/drawing/2014/main" id="{074F877E-EF5A-FE7C-A282-712D5E2E673B}"/>
+              </a:ext>
+            </a:extLst>
+          </p:cNvPr>
+          <p:cNvSpPr txBox="1"/>
+          <p:nvPr/>
+        </p:nvSpPr>
+        <p:spPr>
+          <a:xfrm>
+            <a:off x="2108723" y="6794442"/>
+            <a:ext cx="505267" cy="637547"/>
+          </a:xfrm>
+          <a:prstGeom prst="rect">
+            <a:avLst/>
+          </a:prstGeom>
+          <a:noFill/>
+        </p:spPr>
+        <p:txBody>
+          <a:bodyPr wrap="none" rtlCol="0">
+            <a:spAutoFit/>
+          </a:bodyPr>
+          <a:lstStyle/>
+          <a:p>
+            <a:r>
+              <a:rPr lang="en-US" sz="3543" b="1" dirty="0"/>
+              <a:t>C</a:t>
+            </a:r>
+            <a:endParaRPr lang="en-DK" sz="3543" b="1" dirty="0"/>
+          </a:p>
+        </p:txBody>
+      </p:sp>
+      <p:sp>
+        <p:nvSpPr>
+          <p:cNvPr id="4" name="TextBox 3">
+            <a:extLst>
+              <a:ext uri="{FF2B5EF4-FFF2-40B4-BE49-F238E27FC236}">
+                <a16:creationId xmlns:a16="http://schemas.microsoft.com/office/drawing/2014/main" id="{D113CEE2-94C8-5556-D4DF-BEC8AF6A6FEA}"/>
+              </a:ext>
+            </a:extLst>
+          </p:cNvPr>
+          <p:cNvSpPr txBox="1"/>
+          <p:nvPr/>
+        </p:nvSpPr>
+        <p:spPr>
+          <a:xfrm>
+            <a:off x="11038317" y="6794442"/>
+            <a:ext cx="505267" cy="637547"/>
+          </a:xfrm>
+          <a:prstGeom prst="rect">
+            <a:avLst/>
+          </a:prstGeom>
+          <a:noFill/>
+        </p:spPr>
+        <p:txBody>
+          <a:bodyPr wrap="none" rtlCol="0">
+            <a:spAutoFit/>
+          </a:bodyPr>
+          <a:lstStyle/>
+          <a:p>
+            <a:r>
+              <a:rPr lang="en-US" sz="3543" b="1" dirty="0"/>
+              <a:t>D</a:t>
+            </a:r>
+            <a:endParaRPr lang="en-DK" sz="3543" b="1" dirty="0"/>
+          </a:p>
+        </p:txBody>
+      </p:sp>
+      <p:sp>
+        <p:nvSpPr>
+          <p:cNvPr id="8" name="TextBox 7">
+            <a:extLst>
+              <a:ext uri="{FF2B5EF4-FFF2-40B4-BE49-F238E27FC236}">
+                <a16:creationId xmlns:a16="http://schemas.microsoft.com/office/drawing/2014/main" id="{CD0E51CC-877F-CE41-2BDE-FB81A4BD0172}"/>
+              </a:ext>
+            </a:extLst>
+          </p:cNvPr>
+          <p:cNvSpPr txBox="1"/>
+          <p:nvPr/>
+        </p:nvSpPr>
+        <p:spPr>
+          <a:xfrm>
+            <a:off x="2717077" y="12955842"/>
+            <a:ext cx="8083479" cy="528606"/>
+          </a:xfrm>
+          <a:prstGeom prst="rect">
+            <a:avLst/>
+          </a:prstGeom>
+          <a:noFill/>
+        </p:spPr>
+        <p:txBody>
+          <a:bodyPr wrap="square">
+            <a:spAutoFit/>
+          </a:bodyPr>
+          <a:lstStyle/>
+          <a:p>
+            <a:pPr algn="ctr"/>
+            <a:r>
+              <a:rPr lang="en-DK" sz="2835" dirty="0">
+                <a:latin typeface="Courier New" panose="02070309020205020404" pitchFamily="49" charset="0"/>
+                <a:cs typeface="Courier New" panose="02070309020205020404" pitchFamily="49" charset="0"/>
+              </a:rPr>
+              <a:t>second-cuff="false"</a:t>
+            </a:r>
+          </a:p>
+        </p:txBody>
+      </p:sp>
+      <p:sp>
+        <p:nvSpPr>
+          <p:cNvPr id="10" name="TextBox 9">
+            <a:extLst>
+              <a:ext uri="{FF2B5EF4-FFF2-40B4-BE49-F238E27FC236}">
+                <a16:creationId xmlns:a16="http://schemas.microsoft.com/office/drawing/2014/main" id="{C0DB2525-614A-E830-030E-C22EA67AEFF2}"/>
+              </a:ext>
+            </a:extLst>
+          </p:cNvPr>
+          <p:cNvSpPr txBox="1"/>
+          <p:nvPr/>
+        </p:nvSpPr>
+        <p:spPr>
+          <a:xfrm>
+            <a:off x="11646671" y="12955842"/>
+            <a:ext cx="8321240" cy="528606"/>
+          </a:xfrm>
+          <a:prstGeom prst="rect">
+            <a:avLst/>
+          </a:prstGeom>
+          <a:noFill/>
+        </p:spPr>
+        <p:txBody>
+          <a:bodyPr wrap="square">
+            <a:spAutoFit/>
+          </a:bodyPr>
+          <a:lstStyle/>
+          <a:p>
+            <a:pPr algn="ctr"/>
+            <a:r>
+              <a:rPr lang="en-DK" sz="2835" dirty="0">
+                <a:latin typeface="Courier New" panose="02070309020205020404" pitchFamily="49" charset="0"/>
+                <a:cs typeface="Courier New" panose="02070309020205020404" pitchFamily="49" charset="0"/>
+              </a:rPr>
+              <a:t>second-cuff=“</a:t>
+            </a:r>
+            <a:r>
+              <a:rPr lang="en-GB" sz="2835" dirty="0">
+                <a:latin typeface="Courier New" panose="02070309020205020404" pitchFamily="49" charset="0"/>
+                <a:cs typeface="Courier New" panose="02070309020205020404" pitchFamily="49" charset="0"/>
+              </a:rPr>
+              <a:t>true</a:t>
+            </a:r>
+            <a:r>
+              <a:rPr lang="en-DK" sz="2835" dirty="0">
+                <a:latin typeface="Courier New" panose="02070309020205020404" pitchFamily="49" charset="0"/>
+                <a:cs typeface="Courier New" panose="02070309020205020404" pitchFamily="49" charset="0"/>
+              </a:rPr>
+              <a:t>"</a:t>
+            </a:r>
+          </a:p>
+        </p:txBody>
+      </p:sp>
+      <p:pic>
+        <p:nvPicPr>
+          <p:cNvPr id="12" name="Picture 11">
+            <a:extLst>
+              <a:ext uri="{FF2B5EF4-FFF2-40B4-BE49-F238E27FC236}">
+                <a16:creationId xmlns:a16="http://schemas.microsoft.com/office/drawing/2014/main" id="{C8CE9036-5963-7EAA-B42D-BC11D1F6FFC5}"/>
+              </a:ext>
+            </a:extLst>
+          </p:cNvPr>
+          <p:cNvPicPr>
+            <a:picLocks noChangeAspect="1"/>
+          </p:cNvPicPr>
+          <p:nvPr/>
+        </p:nvPicPr>
+        <p:blipFill>
+          <a:blip r:embed="rId5"/>
+          <a:stretch>
+            <a:fillRect/>
+          </a:stretch>
+        </p:blipFill>
+        <p:spPr>
+          <a:xfrm>
+            <a:off x="2108723" y="7503334"/>
+            <a:ext cx="8929594" cy="5404754"/>
+          </a:xfrm>
+          <a:prstGeom prst="rect">
+            <a:avLst/>
+          </a:prstGeom>
+        </p:spPr>
+      </p:pic>
+      <p:pic>
+        <p:nvPicPr>
+          <p:cNvPr id="13" name="Picture 12">
+            <a:extLst>
+              <a:ext uri="{FF2B5EF4-FFF2-40B4-BE49-F238E27FC236}">
+                <a16:creationId xmlns:a16="http://schemas.microsoft.com/office/drawing/2014/main" id="{2124CACD-5100-48E3-A0FD-64500311B7DF}"/>
+              </a:ext>
+            </a:extLst>
+          </p:cNvPr>
+          <p:cNvPicPr>
+            <a:picLocks noChangeAspect="1"/>
+          </p:cNvPicPr>
+          <p:nvPr/>
+        </p:nvPicPr>
+        <p:blipFill>
+          <a:blip r:embed="rId6"/>
+          <a:stretch>
+            <a:fillRect/>
+          </a:stretch>
+        </p:blipFill>
+        <p:spPr>
+          <a:xfrm>
+            <a:off x="11038317" y="7491987"/>
+            <a:ext cx="8929594" cy="5382598"/>
           </a:xfrm>
           <a:prstGeom prst="rect">
             <a:avLst/>
@@ -6530,7 +6422,7 @@
     </p:spTree>
     <p:extLst>
       <p:ext uri="{BB962C8B-B14F-4D97-AF65-F5344CB8AC3E}">
-        <p14:creationId xmlns:p14="http://schemas.microsoft.com/office/powerpoint/2010/main" val="254473305"/>
+        <p14:creationId xmlns:p14="http://schemas.microsoft.com/office/powerpoint/2010/main" val="1687520235"/>
       </p:ext>
     </p:extLst>
   </p:cSld>
@@ -6541,6 +6433,518 @@
 </file>
 
 <file path=ppt/slides/slide11.xml><?xml version="1.0" encoding="utf-8"?>
+<p:sld xmlns:a="http://schemas.openxmlformats.org/drawingml/2006/main" xmlns:r="http://schemas.openxmlformats.org/officeDocument/2006/relationships" xmlns:p="http://schemas.openxmlformats.org/presentationml/2006/main">
+  <p:cSld>
+    <p:spTree>
+      <p:nvGrpSpPr>
+        <p:cNvPr id="1" name="">
+          <a:extLst>
+            <a:ext uri="{FF2B5EF4-FFF2-40B4-BE49-F238E27FC236}">
+              <a16:creationId xmlns:a16="http://schemas.microsoft.com/office/drawing/2014/main" id="{2A03C425-888E-886C-8702-9EF41C245D6C}"/>
+            </a:ext>
+          </a:extLst>
+        </p:cNvPr>
+        <p:cNvGrpSpPr/>
+        <p:nvPr/>
+      </p:nvGrpSpPr>
+      <p:grpSpPr>
+        <a:xfrm>
+          <a:off x="0" y="0"/>
+          <a:ext cx="0" cy="0"/>
+          <a:chOff x="0" y="0"/>
+          <a:chExt cx="0" cy="0"/>
+        </a:xfrm>
+      </p:grpSpPr>
+      <p:sp>
+        <p:nvSpPr>
+          <p:cNvPr id="2" name="TextBox 1">
+            <a:extLst>
+              <a:ext uri="{FF2B5EF4-FFF2-40B4-BE49-F238E27FC236}">
+                <a16:creationId xmlns:a16="http://schemas.microsoft.com/office/drawing/2014/main" id="{82FBC297-07B8-E259-3D99-65826BD07397}"/>
+              </a:ext>
+            </a:extLst>
+          </p:cNvPr>
+          <p:cNvSpPr txBox="1"/>
+          <p:nvPr/>
+        </p:nvSpPr>
+        <p:spPr>
+          <a:xfrm>
+            <a:off x="1870962" y="1124794"/>
+            <a:ext cx="466794" cy="637547"/>
+          </a:xfrm>
+          <a:prstGeom prst="rect">
+            <a:avLst/>
+          </a:prstGeom>
+          <a:noFill/>
+        </p:spPr>
+        <p:txBody>
+          <a:bodyPr wrap="none" rtlCol="0">
+            <a:spAutoFit/>
+          </a:bodyPr>
+          <a:lstStyle/>
+          <a:p>
+            <a:r>
+              <a:rPr lang="en-GB" sz="3543" b="1" dirty="0"/>
+              <a:t>A</a:t>
+            </a:r>
+            <a:endParaRPr lang="en-DK" sz="3543" b="1" dirty="0"/>
+          </a:p>
+        </p:txBody>
+      </p:sp>
+      <p:sp>
+        <p:nvSpPr>
+          <p:cNvPr id="3" name="TextBox 2">
+            <a:extLst>
+              <a:ext uri="{FF2B5EF4-FFF2-40B4-BE49-F238E27FC236}">
+                <a16:creationId xmlns:a16="http://schemas.microsoft.com/office/drawing/2014/main" id="{F0D45F0D-B877-1194-B331-39558D2629E0}"/>
+              </a:ext>
+            </a:extLst>
+          </p:cNvPr>
+          <p:cNvSpPr txBox="1"/>
+          <p:nvPr/>
+        </p:nvSpPr>
+        <p:spPr>
+          <a:xfrm>
+            <a:off x="10100968" y="1124794"/>
+            <a:ext cx="465192" cy="637547"/>
+          </a:xfrm>
+          <a:prstGeom prst="rect">
+            <a:avLst/>
+          </a:prstGeom>
+          <a:noFill/>
+        </p:spPr>
+        <p:txBody>
+          <a:bodyPr wrap="none" rtlCol="0">
+            <a:spAutoFit/>
+          </a:bodyPr>
+          <a:lstStyle/>
+          <a:p>
+            <a:r>
+              <a:rPr lang="en-GB" sz="3543" b="1" dirty="0"/>
+              <a:t>B</a:t>
+            </a:r>
+            <a:endParaRPr lang="en-DK" sz="3543" b="1" dirty="0"/>
+          </a:p>
+        </p:txBody>
+      </p:sp>
+      <p:sp>
+        <p:nvSpPr>
+          <p:cNvPr id="4" name="TextBox 3">
+            <a:extLst>
+              <a:ext uri="{FF2B5EF4-FFF2-40B4-BE49-F238E27FC236}">
+                <a16:creationId xmlns:a16="http://schemas.microsoft.com/office/drawing/2014/main" id="{73C6C390-8E6B-29EC-2644-9CDDC29CF81B}"/>
+              </a:ext>
+            </a:extLst>
+          </p:cNvPr>
+          <p:cNvSpPr txBox="1"/>
+          <p:nvPr/>
+        </p:nvSpPr>
+        <p:spPr>
+          <a:xfrm>
+            <a:off x="2175139" y="6318156"/>
+            <a:ext cx="8083479" cy="855619"/>
+          </a:xfrm>
+          <a:prstGeom prst="rect">
+            <a:avLst/>
+          </a:prstGeom>
+          <a:noFill/>
+        </p:spPr>
+        <p:txBody>
+          <a:bodyPr wrap="square">
+            <a:spAutoFit/>
+          </a:bodyPr>
+          <a:lstStyle/>
+          <a:p>
+            <a:pPr algn="ctr"/>
+            <a:r>
+              <a:rPr lang="en-GB" sz="2480" dirty="0">
+                <a:latin typeface="Courier New" panose="02070309020205020404" pitchFamily="49" charset="0"/>
+                <a:cs typeface="Courier New" panose="02070309020205020404" pitchFamily="49" charset="0"/>
+              </a:rPr>
+              <a:t>delta-conditional-pressure="10“</a:t>
+            </a:r>
+          </a:p>
+          <a:p>
+            <a:pPr algn="ctr"/>
+            <a:r>
+              <a:rPr lang="en-GB" sz="2480" dirty="0">
+                <a:latin typeface="Courier New" panose="02070309020205020404" pitchFamily="49" charset="0"/>
+                <a:cs typeface="Courier New" panose="02070309020205020404" pitchFamily="49" charset="0"/>
+              </a:rPr>
+              <a:t>conditioning-time="0"</a:t>
+            </a:r>
+            <a:endParaRPr lang="en-DK" sz="2480" dirty="0">
+              <a:latin typeface="Courier New" panose="02070309020205020404" pitchFamily="49" charset="0"/>
+              <a:cs typeface="Courier New" panose="02070309020205020404" pitchFamily="49" charset="0"/>
+            </a:endParaRPr>
+          </a:p>
+        </p:txBody>
+      </p:sp>
+      <p:sp>
+        <p:nvSpPr>
+          <p:cNvPr id="5" name="TextBox 4">
+            <a:extLst>
+              <a:ext uri="{FF2B5EF4-FFF2-40B4-BE49-F238E27FC236}">
+                <a16:creationId xmlns:a16="http://schemas.microsoft.com/office/drawing/2014/main" id="{31744852-A411-5FFE-EB0C-452B3DDC5239}"/>
+              </a:ext>
+            </a:extLst>
+          </p:cNvPr>
+          <p:cNvSpPr txBox="1"/>
+          <p:nvPr/>
+        </p:nvSpPr>
+        <p:spPr>
+          <a:xfrm>
+            <a:off x="9863208" y="6318156"/>
+            <a:ext cx="8321240" cy="855619"/>
+          </a:xfrm>
+          <a:prstGeom prst="rect">
+            <a:avLst/>
+          </a:prstGeom>
+          <a:noFill/>
+        </p:spPr>
+        <p:txBody>
+          <a:bodyPr wrap="square">
+            <a:spAutoFit/>
+          </a:bodyPr>
+          <a:lstStyle/>
+          <a:p>
+            <a:pPr algn="ctr"/>
+            <a:r>
+              <a:rPr lang="en-GB" sz="2480" dirty="0">
+                <a:latin typeface="Courier New" panose="02070309020205020404" pitchFamily="49" charset="0"/>
+                <a:cs typeface="Courier New" panose="02070309020205020404" pitchFamily="49" charset="0"/>
+              </a:rPr>
+              <a:t>delta-conditional-pressure="10“</a:t>
+            </a:r>
+          </a:p>
+          <a:p>
+            <a:pPr algn="ctr"/>
+            <a:r>
+              <a:rPr lang="en-GB" sz="2480" dirty="0">
+                <a:latin typeface="Courier New" panose="02070309020205020404" pitchFamily="49" charset="0"/>
+                <a:cs typeface="Courier New" panose="02070309020205020404" pitchFamily="49" charset="0"/>
+              </a:rPr>
+              <a:t>conditioning-time="30"</a:t>
+            </a:r>
+            <a:endParaRPr lang="en-DK" sz="2480" dirty="0">
+              <a:latin typeface="Courier New" panose="02070309020205020404" pitchFamily="49" charset="0"/>
+              <a:cs typeface="Courier New" panose="02070309020205020404" pitchFamily="49" charset="0"/>
+            </a:endParaRPr>
+          </a:p>
+        </p:txBody>
+      </p:sp>
+      <p:sp>
+        <p:nvSpPr>
+          <p:cNvPr id="8" name="TextBox 7">
+            <a:extLst>
+              <a:ext uri="{FF2B5EF4-FFF2-40B4-BE49-F238E27FC236}">
+                <a16:creationId xmlns:a16="http://schemas.microsoft.com/office/drawing/2014/main" id="{2ADC7E39-8E73-54E3-188D-789DB8AB33F2}"/>
+              </a:ext>
+            </a:extLst>
+          </p:cNvPr>
+          <p:cNvSpPr txBox="1"/>
+          <p:nvPr/>
+        </p:nvSpPr>
+        <p:spPr>
+          <a:xfrm>
+            <a:off x="1870963" y="6789119"/>
+            <a:ext cx="505267" cy="637547"/>
+          </a:xfrm>
+          <a:prstGeom prst="rect">
+            <a:avLst/>
+          </a:prstGeom>
+          <a:noFill/>
+        </p:spPr>
+        <p:txBody>
+          <a:bodyPr wrap="none" rtlCol="0">
+            <a:spAutoFit/>
+          </a:bodyPr>
+          <a:lstStyle/>
+          <a:p>
+            <a:r>
+              <a:rPr lang="en-GB" sz="3543" b="1" dirty="0"/>
+              <a:t>C</a:t>
+            </a:r>
+            <a:endParaRPr lang="en-DK" sz="3543" b="1" dirty="0"/>
+          </a:p>
+        </p:txBody>
+      </p:sp>
+      <p:sp>
+        <p:nvSpPr>
+          <p:cNvPr id="9" name="TextBox 8">
+            <a:extLst>
+              <a:ext uri="{FF2B5EF4-FFF2-40B4-BE49-F238E27FC236}">
+                <a16:creationId xmlns:a16="http://schemas.microsoft.com/office/drawing/2014/main" id="{79742922-EDD3-4273-98A4-7FB1FD5782ED}"/>
+              </a:ext>
+            </a:extLst>
+          </p:cNvPr>
+          <p:cNvSpPr txBox="1"/>
+          <p:nvPr/>
+        </p:nvSpPr>
+        <p:spPr>
+          <a:xfrm>
+            <a:off x="10100969" y="6789119"/>
+            <a:ext cx="505267" cy="637547"/>
+          </a:xfrm>
+          <a:prstGeom prst="rect">
+            <a:avLst/>
+          </a:prstGeom>
+          <a:noFill/>
+        </p:spPr>
+        <p:txBody>
+          <a:bodyPr wrap="none" rtlCol="0">
+            <a:spAutoFit/>
+          </a:bodyPr>
+          <a:lstStyle/>
+          <a:p>
+            <a:r>
+              <a:rPr lang="en-GB" sz="3543" b="1" dirty="0"/>
+              <a:t>D</a:t>
+            </a:r>
+            <a:endParaRPr lang="en-DK" sz="3543" b="1" dirty="0"/>
+          </a:p>
+        </p:txBody>
+      </p:sp>
+      <p:sp>
+        <p:nvSpPr>
+          <p:cNvPr id="10" name="TextBox 9">
+            <a:extLst>
+              <a:ext uri="{FF2B5EF4-FFF2-40B4-BE49-F238E27FC236}">
+                <a16:creationId xmlns:a16="http://schemas.microsoft.com/office/drawing/2014/main" id="{26C72CE9-F630-D917-764B-BC15F8330FF7}"/>
+              </a:ext>
+            </a:extLst>
+          </p:cNvPr>
+          <p:cNvSpPr txBox="1"/>
+          <p:nvPr/>
+        </p:nvSpPr>
+        <p:spPr>
+          <a:xfrm>
+            <a:off x="2175139" y="11960656"/>
+            <a:ext cx="8083479" cy="855619"/>
+          </a:xfrm>
+          <a:prstGeom prst="rect">
+            <a:avLst/>
+          </a:prstGeom>
+          <a:noFill/>
+        </p:spPr>
+        <p:txBody>
+          <a:bodyPr wrap="square">
+            <a:spAutoFit/>
+          </a:bodyPr>
+          <a:lstStyle/>
+          <a:p>
+            <a:pPr algn="ctr"/>
+            <a:r>
+              <a:rPr lang="en-GB" sz="2480" dirty="0">
+                <a:latin typeface="Courier New" panose="02070309020205020404" pitchFamily="49" charset="0"/>
+                <a:cs typeface="Courier New" panose="02070309020205020404" pitchFamily="49" charset="0"/>
+              </a:rPr>
+              <a:t>delta-conditional-pressure="0“</a:t>
+            </a:r>
+          </a:p>
+          <a:p>
+            <a:pPr algn="ctr"/>
+            <a:r>
+              <a:rPr lang="en-GB" sz="2480" dirty="0">
+                <a:latin typeface="Courier New" panose="02070309020205020404" pitchFamily="49" charset="0"/>
+                <a:cs typeface="Courier New" panose="02070309020205020404" pitchFamily="49" charset="0"/>
+              </a:rPr>
+              <a:t>conditioning-time="0"</a:t>
+            </a:r>
+            <a:endParaRPr lang="en-DK" sz="2480" dirty="0">
+              <a:latin typeface="Courier New" panose="02070309020205020404" pitchFamily="49" charset="0"/>
+              <a:cs typeface="Courier New" panose="02070309020205020404" pitchFamily="49" charset="0"/>
+            </a:endParaRPr>
+          </a:p>
+        </p:txBody>
+      </p:sp>
+      <p:sp>
+        <p:nvSpPr>
+          <p:cNvPr id="11" name="TextBox 10">
+            <a:extLst>
+              <a:ext uri="{FF2B5EF4-FFF2-40B4-BE49-F238E27FC236}">
+                <a16:creationId xmlns:a16="http://schemas.microsoft.com/office/drawing/2014/main" id="{29C9F5F5-B0FC-A2AD-638D-50A91912505F}"/>
+              </a:ext>
+            </a:extLst>
+          </p:cNvPr>
+          <p:cNvSpPr txBox="1"/>
+          <p:nvPr/>
+        </p:nvSpPr>
+        <p:spPr>
+          <a:xfrm>
+            <a:off x="9529556" y="11960656"/>
+            <a:ext cx="8321240" cy="855619"/>
+          </a:xfrm>
+          <a:prstGeom prst="rect">
+            <a:avLst/>
+          </a:prstGeom>
+          <a:noFill/>
+        </p:spPr>
+        <p:txBody>
+          <a:bodyPr wrap="square">
+            <a:spAutoFit/>
+          </a:bodyPr>
+          <a:lstStyle/>
+          <a:p>
+            <a:pPr algn="ctr"/>
+            <a:r>
+              <a:rPr lang="en-GB" sz="2480" dirty="0">
+                <a:latin typeface="Courier New" panose="02070309020205020404" pitchFamily="49" charset="0"/>
+                <a:cs typeface="Courier New" panose="02070309020205020404" pitchFamily="49" charset="0"/>
+              </a:rPr>
+              <a:t>delta-conditional-pressure="0“</a:t>
+            </a:r>
+          </a:p>
+          <a:p>
+            <a:pPr algn="ctr"/>
+            <a:r>
+              <a:rPr lang="en-GB" sz="2480" dirty="0">
+                <a:latin typeface="Courier New" panose="02070309020205020404" pitchFamily="49" charset="0"/>
+                <a:cs typeface="Courier New" panose="02070309020205020404" pitchFamily="49" charset="0"/>
+              </a:rPr>
+              <a:t>conditioning-time="30"</a:t>
+            </a:r>
+            <a:endParaRPr lang="en-DK" sz="2480" dirty="0">
+              <a:latin typeface="Courier New" panose="02070309020205020404" pitchFamily="49" charset="0"/>
+              <a:cs typeface="Courier New" panose="02070309020205020404" pitchFamily="49" charset="0"/>
+            </a:endParaRPr>
+          </a:p>
+        </p:txBody>
+      </p:sp>
+      <p:pic>
+        <p:nvPicPr>
+          <p:cNvPr id="23" name="Picture 22">
+            <a:extLst>
+              <a:ext uri="{FF2B5EF4-FFF2-40B4-BE49-F238E27FC236}">
+                <a16:creationId xmlns:a16="http://schemas.microsoft.com/office/drawing/2014/main" id="{7D2654F7-E6E3-8D26-3020-047420F69A44}"/>
+              </a:ext>
+            </a:extLst>
+          </p:cNvPr>
+          <p:cNvPicPr>
+            <a:picLocks noChangeAspect="1"/>
+          </p:cNvPicPr>
+          <p:nvPr/>
+        </p:nvPicPr>
+        <p:blipFill>
+          <a:blip r:embed="rId3"/>
+          <a:stretch>
+            <a:fillRect/>
+          </a:stretch>
+        </p:blipFill>
+        <p:spPr>
+          <a:xfrm>
+            <a:off x="1870962" y="1794423"/>
+            <a:ext cx="7653938" cy="4630159"/>
+          </a:xfrm>
+          <a:prstGeom prst="rect">
+            <a:avLst/>
+          </a:prstGeom>
+        </p:spPr>
+      </p:pic>
+      <p:pic>
+        <p:nvPicPr>
+          <p:cNvPr id="25" name="Picture 24">
+            <a:extLst>
+              <a:ext uri="{FF2B5EF4-FFF2-40B4-BE49-F238E27FC236}">
+                <a16:creationId xmlns:a16="http://schemas.microsoft.com/office/drawing/2014/main" id="{D489A1A0-CA50-B327-A4B4-0399839613F5}"/>
+              </a:ext>
+            </a:extLst>
+          </p:cNvPr>
+          <p:cNvPicPr>
+            <a:picLocks noChangeAspect="1"/>
+          </p:cNvPicPr>
+          <p:nvPr/>
+        </p:nvPicPr>
+        <p:blipFill>
+          <a:blip r:embed="rId4"/>
+          <a:stretch>
+            <a:fillRect/>
+          </a:stretch>
+        </p:blipFill>
+        <p:spPr>
+          <a:xfrm>
+            <a:off x="1870962" y="7498011"/>
+            <a:ext cx="7653938" cy="4632647"/>
+          </a:xfrm>
+          <a:prstGeom prst="rect">
+            <a:avLst/>
+          </a:prstGeom>
+        </p:spPr>
+      </p:pic>
+      <p:pic>
+        <p:nvPicPr>
+          <p:cNvPr id="27" name="Picture 26">
+            <a:extLst>
+              <a:ext uri="{FF2B5EF4-FFF2-40B4-BE49-F238E27FC236}">
+                <a16:creationId xmlns:a16="http://schemas.microsoft.com/office/drawing/2014/main" id="{CCBD8EB3-1358-8B4F-D299-042AE387156D}"/>
+              </a:ext>
+            </a:extLst>
+          </p:cNvPr>
+          <p:cNvPicPr>
+            <a:picLocks noChangeAspect="1"/>
+          </p:cNvPicPr>
+          <p:nvPr/>
+        </p:nvPicPr>
+        <p:blipFill>
+          <a:blip r:embed="rId5"/>
+          <a:stretch>
+            <a:fillRect/>
+          </a:stretch>
+        </p:blipFill>
+        <p:spPr>
+          <a:xfrm>
+            <a:off x="10100968" y="1794423"/>
+            <a:ext cx="7653938" cy="4582914"/>
+          </a:xfrm>
+          <a:prstGeom prst="rect">
+            <a:avLst/>
+          </a:prstGeom>
+        </p:spPr>
+      </p:pic>
+      <p:pic>
+        <p:nvPicPr>
+          <p:cNvPr id="29" name="Picture 28">
+            <a:extLst>
+              <a:ext uri="{FF2B5EF4-FFF2-40B4-BE49-F238E27FC236}">
+                <a16:creationId xmlns:a16="http://schemas.microsoft.com/office/drawing/2014/main" id="{B575FE4D-1AD8-D849-2C0E-FFFD43AF901D}"/>
+              </a:ext>
+            </a:extLst>
+          </p:cNvPr>
+          <p:cNvPicPr>
+            <a:picLocks noChangeAspect="1"/>
+          </p:cNvPicPr>
+          <p:nvPr/>
+        </p:nvPicPr>
+        <p:blipFill>
+          <a:blip r:embed="rId6"/>
+          <a:stretch>
+            <a:fillRect/>
+          </a:stretch>
+        </p:blipFill>
+        <p:spPr>
+          <a:xfrm>
+            <a:off x="10100968" y="7498012"/>
+            <a:ext cx="7653938" cy="4597102"/>
+          </a:xfrm>
+          <a:prstGeom prst="rect">
+            <a:avLst/>
+          </a:prstGeom>
+        </p:spPr>
+      </p:pic>
+    </p:spTree>
+    <p:extLst>
+      <p:ext uri="{BB962C8B-B14F-4D97-AF65-F5344CB8AC3E}">
+        <p14:creationId xmlns:p14="http://schemas.microsoft.com/office/powerpoint/2010/main" val="3314536849"/>
+      </p:ext>
+    </p:extLst>
+  </p:cSld>
+  <p:clrMapOvr>
+    <a:masterClrMapping/>
+  </p:clrMapOvr>
+</p:sld>
+</file>
+
+<file path=ppt/slides/slide12.xml><?xml version="1.0" encoding="utf-8"?>
 <p:sld xmlns:a="http://schemas.openxmlformats.org/drawingml/2006/main" xmlns:r="http://schemas.openxmlformats.org/officeDocument/2006/relationships" xmlns:p="http://schemas.openxmlformats.org/presentationml/2006/main">
   <p:cSld>
     <p:spTree>
@@ -6559,10 +6963,10 @@
       </p:grpSpPr>
       <p:pic>
         <p:nvPicPr>
-          <p:cNvPr id="3" name="Picture 2">
-            <a:extLst>
-              <a:ext uri="{FF2B5EF4-FFF2-40B4-BE49-F238E27FC236}">
-                <a16:creationId xmlns:a16="http://schemas.microsoft.com/office/drawing/2014/main" id="{2D567D92-1D7A-4407-7B60-AEBD6C9E3233}"/>
+          <p:cNvPr id="2" name="Picture 1">
+            <a:extLst>
+              <a:ext uri="{FF2B5EF4-FFF2-40B4-BE49-F238E27FC236}">
+                <a16:creationId xmlns:a16="http://schemas.microsoft.com/office/drawing/2014/main" id="{4B2E835F-9788-4A9E-1CB6-286FC6F201AE}"/>
               </a:ext>
             </a:extLst>
           </p:cNvPr>
@@ -6579,7 +6983,7 @@
         </p:blipFill>
         <p:spPr>
           <a:xfrm>
-            <a:off x="2108723" y="1732774"/>
+            <a:off x="2108723" y="1026195"/>
             <a:ext cx="8929594" cy="5377107"/>
           </a:xfrm>
           <a:prstGeom prst="rect">
@@ -6587,12 +6991,84 @@
           </a:prstGeom>
         </p:spPr>
       </p:pic>
+      <p:sp>
+        <p:nvSpPr>
+          <p:cNvPr id="4" name="TextBox 3">
+            <a:extLst>
+              <a:ext uri="{FF2B5EF4-FFF2-40B4-BE49-F238E27FC236}">
+                <a16:creationId xmlns:a16="http://schemas.microsoft.com/office/drawing/2014/main" id="{D3D2F7AB-EDED-9987-110A-93FF9F0EE147}"/>
+              </a:ext>
+            </a:extLst>
+          </p:cNvPr>
+          <p:cNvSpPr txBox="1"/>
+          <p:nvPr/>
+        </p:nvSpPr>
+        <p:spPr>
+          <a:xfrm>
+            <a:off x="2108723" y="248171"/>
+            <a:ext cx="466794" cy="637547"/>
+          </a:xfrm>
+          <a:prstGeom prst="rect">
+            <a:avLst/>
+          </a:prstGeom>
+          <a:noFill/>
+        </p:spPr>
+        <p:txBody>
+          <a:bodyPr wrap="none" rtlCol="0">
+            <a:spAutoFit/>
+          </a:bodyPr>
+          <a:lstStyle/>
+          <a:p>
+            <a:r>
+              <a:rPr lang="en-GB" sz="3543" b="1" dirty="0"/>
+              <a:t>A</a:t>
+            </a:r>
+            <a:endParaRPr lang="en-DK" sz="3543" b="1" dirty="0"/>
+          </a:p>
+        </p:txBody>
+      </p:sp>
+      <p:sp>
+        <p:nvSpPr>
+          <p:cNvPr id="5" name="TextBox 4">
+            <a:extLst>
+              <a:ext uri="{FF2B5EF4-FFF2-40B4-BE49-F238E27FC236}">
+                <a16:creationId xmlns:a16="http://schemas.microsoft.com/office/drawing/2014/main" id="{ED0A835D-47CB-F121-68C0-87BA17B569C8}"/>
+              </a:ext>
+            </a:extLst>
+          </p:cNvPr>
+          <p:cNvSpPr txBox="1"/>
+          <p:nvPr/>
+        </p:nvSpPr>
+        <p:spPr>
+          <a:xfrm>
+            <a:off x="11038317" y="248171"/>
+            <a:ext cx="465192" cy="637547"/>
+          </a:xfrm>
+          <a:prstGeom prst="rect">
+            <a:avLst/>
+          </a:prstGeom>
+          <a:noFill/>
+        </p:spPr>
+        <p:txBody>
+          <a:bodyPr wrap="none" rtlCol="0">
+            <a:spAutoFit/>
+          </a:bodyPr>
+          <a:lstStyle/>
+          <a:p>
+            <a:r>
+              <a:rPr lang="en-GB" sz="3543" b="1" dirty="0"/>
+              <a:t>B</a:t>
+            </a:r>
+            <a:endParaRPr lang="en-DK" sz="3543" b="1" dirty="0"/>
+          </a:p>
+        </p:txBody>
+      </p:sp>
       <p:pic>
         <p:nvPicPr>
-          <p:cNvPr id="5" name="Picture 4">
-            <a:extLst>
-              <a:ext uri="{FF2B5EF4-FFF2-40B4-BE49-F238E27FC236}">
-                <a16:creationId xmlns:a16="http://schemas.microsoft.com/office/drawing/2014/main" id="{C8AFEC52-3815-9C68-F89C-CAF6C6F3021A}"/>
+          <p:cNvPr id="9" name="Picture 8">
+            <a:extLst>
+              <a:ext uri="{FF2B5EF4-FFF2-40B4-BE49-F238E27FC236}">
+                <a16:creationId xmlns:a16="http://schemas.microsoft.com/office/drawing/2014/main" id="{40825D57-0C6A-B345-7828-E6E19D1CE261}"/>
               </a:ext>
             </a:extLst>
           </p:cNvPr>
@@ -6609,8 +7085,8 @@
         </p:blipFill>
         <p:spPr>
           <a:xfrm>
-            <a:off x="11038317" y="1721807"/>
-            <a:ext cx="8929594" cy="5388074"/>
+            <a:off x="11038317" y="1001724"/>
+            <a:ext cx="8929594" cy="5355017"/>
           </a:xfrm>
           <a:prstGeom prst="rect">
             <a:avLst/>
@@ -6619,10 +7095,10 @@
       </p:pic>
       <p:sp>
         <p:nvSpPr>
-          <p:cNvPr id="6" name="TextBox 5">
-            <a:extLst>
-              <a:ext uri="{FF2B5EF4-FFF2-40B4-BE49-F238E27FC236}">
-                <a16:creationId xmlns:a16="http://schemas.microsoft.com/office/drawing/2014/main" id="{8A4AC4C8-78E4-C069-9A70-9801603FA761}"/>
+          <p:cNvPr id="3" name="TextBox 2">
+            <a:extLst>
+              <a:ext uri="{FF2B5EF4-FFF2-40B4-BE49-F238E27FC236}">
+                <a16:creationId xmlns:a16="http://schemas.microsoft.com/office/drawing/2014/main" id="{8A32358C-FBC6-BAF8-8092-1C8DCD637B70}"/>
               </a:ext>
             </a:extLst>
           </p:cNvPr>
@@ -6631,8 +7107,8 @@
         </p:nvSpPr>
         <p:spPr>
           <a:xfrm>
-            <a:off x="2108723" y="954750"/>
-            <a:ext cx="466794" cy="637547"/>
+            <a:off x="2108723" y="6087858"/>
+            <a:ext cx="505267" cy="637547"/>
           </a:xfrm>
           <a:prstGeom prst="rect">
             <a:avLst/>
@@ -6646,8 +7122,8 @@
           <a:lstStyle/>
           <a:p>
             <a:r>
-              <a:rPr lang="en-GB" sz="3543" b="1" dirty="0"/>
-              <a:t>A</a:t>
+              <a:rPr lang="en-US" sz="3543" b="1" dirty="0"/>
+              <a:t>C</a:t>
             </a:r>
             <a:endParaRPr lang="en-DK" sz="3543" b="1" dirty="0"/>
           </a:p>
@@ -6655,10 +7131,10 @@
       </p:sp>
       <p:sp>
         <p:nvSpPr>
-          <p:cNvPr id="7" name="TextBox 6">
-            <a:extLst>
-              <a:ext uri="{FF2B5EF4-FFF2-40B4-BE49-F238E27FC236}">
-                <a16:creationId xmlns:a16="http://schemas.microsoft.com/office/drawing/2014/main" id="{13440474-ACFE-8967-E740-AFD0293118CB}"/>
+          <p:cNvPr id="8" name="TextBox 7">
+            <a:extLst>
+              <a:ext uri="{FF2B5EF4-FFF2-40B4-BE49-F238E27FC236}">
+                <a16:creationId xmlns:a16="http://schemas.microsoft.com/office/drawing/2014/main" id="{5FAD2A63-A019-9CE3-AB08-AE5EB0C62E5E}"/>
               </a:ext>
             </a:extLst>
           </p:cNvPr>
@@ -6667,8 +7143,8 @@
         </p:nvSpPr>
         <p:spPr>
           <a:xfrm>
-            <a:off x="11038317" y="954750"/>
-            <a:ext cx="465192" cy="637547"/>
+            <a:off x="11038317" y="6087858"/>
+            <a:ext cx="505267" cy="637547"/>
           </a:xfrm>
           <a:prstGeom prst="rect">
             <a:avLst/>
@@ -6682,8 +7158,8 @@
           <a:lstStyle/>
           <a:p>
             <a:r>
-              <a:rPr lang="en-GB" sz="3543" b="1" dirty="0"/>
-              <a:t>B</a:t>
+              <a:rPr lang="en-US" sz="3543" b="1" dirty="0"/>
+              <a:t>D</a:t>
             </a:r>
             <a:endParaRPr lang="en-DK" sz="3543" b="1" dirty="0"/>
           </a:p>
@@ -6691,10 +7167,10 @@
       </p:sp>
       <p:sp>
         <p:nvSpPr>
-          <p:cNvPr id="2" name="TextBox 1">
-            <a:extLst>
-              <a:ext uri="{FF2B5EF4-FFF2-40B4-BE49-F238E27FC236}">
-                <a16:creationId xmlns:a16="http://schemas.microsoft.com/office/drawing/2014/main" id="{074F877E-EF5A-FE7C-A282-712D5E2E673B}"/>
+          <p:cNvPr id="10" name="TextBox 9">
+            <a:extLst>
+              <a:ext uri="{FF2B5EF4-FFF2-40B4-BE49-F238E27FC236}">
+                <a16:creationId xmlns:a16="http://schemas.microsoft.com/office/drawing/2014/main" id="{C20292EC-BA8A-1248-EF67-3446775989E1}"/>
               </a:ext>
             </a:extLst>
           </p:cNvPr>
@@ -6703,8 +7179,8 @@
         </p:nvSpPr>
         <p:spPr>
           <a:xfrm>
-            <a:off x="2108723" y="6794442"/>
-            <a:ext cx="505267" cy="637547"/>
+            <a:off x="2717077" y="12249258"/>
+            <a:ext cx="8083479" cy="528606"/>
           </a:xfrm>
           <a:prstGeom prst="rect">
             <a:avLst/>
@@ -6712,25 +7188,32 @@
           <a:noFill/>
         </p:spPr>
         <p:txBody>
-          <a:bodyPr wrap="none" rtlCol="0">
+          <a:bodyPr wrap="square">
             <a:spAutoFit/>
           </a:bodyPr>
           <a:lstStyle/>
           <a:p>
-            <a:r>
-              <a:rPr lang="en-US" sz="3543" b="1" dirty="0"/>
-              <a:t>C</a:t>
-            </a:r>
-            <a:endParaRPr lang="en-DK" sz="3543" b="1" dirty="0"/>
-          </a:p>
-        </p:txBody>
-      </p:sp>
-      <p:sp>
-        <p:nvSpPr>
-          <p:cNvPr id="4" name="TextBox 3">
-            <a:extLst>
-              <a:ext uri="{FF2B5EF4-FFF2-40B4-BE49-F238E27FC236}">
-                <a16:creationId xmlns:a16="http://schemas.microsoft.com/office/drawing/2014/main" id="{D113CEE2-94C8-5556-D4DF-BEC8AF6A6FEA}"/>
+            <a:pPr algn="ctr"/>
+            <a:r>
+              <a:rPr lang="en-GB" sz="2835" dirty="0">
+                <a:latin typeface="Courier New" panose="02070309020205020404" pitchFamily="49" charset="0"/>
+                <a:cs typeface="Courier New" panose="02070309020205020404" pitchFamily="49" charset="0"/>
+              </a:rPr>
+              <a:t>stop-mode="stop-on-maximal-rating"</a:t>
+            </a:r>
+            <a:endParaRPr lang="en-DK" sz="2835" dirty="0">
+              <a:latin typeface="Courier New" panose="02070309020205020404" pitchFamily="49" charset="0"/>
+              <a:cs typeface="Courier New" panose="02070309020205020404" pitchFamily="49" charset="0"/>
+            </a:endParaRPr>
+          </a:p>
+        </p:txBody>
+      </p:sp>
+      <p:sp>
+        <p:nvSpPr>
+          <p:cNvPr id="11" name="TextBox 10">
+            <a:extLst>
+              <a:ext uri="{FF2B5EF4-FFF2-40B4-BE49-F238E27FC236}">
+                <a16:creationId xmlns:a16="http://schemas.microsoft.com/office/drawing/2014/main" id="{9691AA1E-6883-E41C-B5E1-5BF14A75740A}"/>
               </a:ext>
             </a:extLst>
           </p:cNvPr>
@@ -6739,8 +7222,8 @@
         </p:nvSpPr>
         <p:spPr>
           <a:xfrm>
-            <a:off x="11038317" y="6794442"/>
-            <a:ext cx="505267" cy="637547"/>
+            <a:off x="11646671" y="12249258"/>
+            <a:ext cx="8321240" cy="528606"/>
           </a:xfrm>
           <a:prstGeom prst="rect">
             <a:avLst/>
@@ -6748,108 +7231,23 @@
           <a:noFill/>
         </p:spPr>
         <p:txBody>
-          <a:bodyPr wrap="none" rtlCol="0">
-            <a:spAutoFit/>
-          </a:bodyPr>
-          <a:lstStyle/>
-          <a:p>
-            <a:r>
-              <a:rPr lang="en-US" sz="3543" b="1" dirty="0"/>
-              <a:t>D</a:t>
-            </a:r>
-            <a:endParaRPr lang="en-DK" sz="3543" b="1" dirty="0"/>
-          </a:p>
-        </p:txBody>
-      </p:sp>
-      <p:sp>
-        <p:nvSpPr>
-          <p:cNvPr id="8" name="TextBox 7">
-            <a:extLst>
-              <a:ext uri="{FF2B5EF4-FFF2-40B4-BE49-F238E27FC236}">
-                <a16:creationId xmlns:a16="http://schemas.microsoft.com/office/drawing/2014/main" id="{CD0E51CC-877F-CE41-2BDE-FB81A4BD0172}"/>
-              </a:ext>
-            </a:extLst>
-          </p:cNvPr>
-          <p:cNvSpPr txBox="1"/>
-          <p:nvPr/>
-        </p:nvSpPr>
-        <p:spPr>
-          <a:xfrm>
-            <a:off x="2717077" y="12955842"/>
-            <a:ext cx="8083479" cy="528606"/>
-          </a:xfrm>
-          <a:prstGeom prst="rect">
-            <a:avLst/>
-          </a:prstGeom>
-          <a:noFill/>
-        </p:spPr>
-        <p:txBody>
           <a:bodyPr wrap="square">
             <a:spAutoFit/>
           </a:bodyPr>
           <a:lstStyle/>
           <a:p>
             <a:pPr algn="ctr"/>
-            <a:r>
-              <a:rPr lang="en-DK" sz="2835" dirty="0">
-                <a:latin typeface="Courier New" panose="02070309020205020404" pitchFamily="49" charset="0"/>
-                <a:cs typeface="Courier New" panose="02070309020205020404" pitchFamily="49" charset="0"/>
-              </a:rPr>
-              <a:t>second-cuff="false"</a:t>
-            </a:r>
-          </a:p>
-        </p:txBody>
-      </p:sp>
-      <p:sp>
-        <p:nvSpPr>
-          <p:cNvPr id="10" name="TextBox 9">
-            <a:extLst>
-              <a:ext uri="{FF2B5EF4-FFF2-40B4-BE49-F238E27FC236}">
-                <a16:creationId xmlns:a16="http://schemas.microsoft.com/office/drawing/2014/main" id="{C0DB2525-614A-E830-030E-C22EA67AEFF2}"/>
-              </a:ext>
-            </a:extLst>
-          </p:cNvPr>
-          <p:cNvSpPr txBox="1"/>
-          <p:nvPr/>
-        </p:nvSpPr>
-        <p:spPr>
-          <a:xfrm>
-            <a:off x="11646671" y="12955842"/>
-            <a:ext cx="8321240" cy="528606"/>
-          </a:xfrm>
-          <a:prstGeom prst="rect">
-            <a:avLst/>
-          </a:prstGeom>
-          <a:noFill/>
-        </p:spPr>
-        <p:txBody>
-          <a:bodyPr wrap="square">
-            <a:spAutoFit/>
-          </a:bodyPr>
-          <a:lstStyle/>
-          <a:p>
-            <a:pPr algn="ctr"/>
-            <a:r>
-              <a:rPr lang="en-DK" sz="2835" dirty="0">
-                <a:latin typeface="Courier New" panose="02070309020205020404" pitchFamily="49" charset="0"/>
-                <a:cs typeface="Courier New" panose="02070309020205020404" pitchFamily="49" charset="0"/>
-              </a:rPr>
-              <a:t>second-cuff=“</a:t>
-            </a:r>
             <a:r>
               <a:rPr lang="en-GB" sz="2835" dirty="0">
                 <a:latin typeface="Courier New" panose="02070309020205020404" pitchFamily="49" charset="0"/>
                 <a:cs typeface="Courier New" panose="02070309020205020404" pitchFamily="49" charset="0"/>
               </a:rPr>
-              <a:t>true</a:t>
-            </a:r>
-            <a:r>
-              <a:rPr lang="en-DK" sz="2835" dirty="0">
-                <a:latin typeface="Courier New" panose="02070309020205020404" pitchFamily="49" charset="0"/>
-                <a:cs typeface="Courier New" panose="02070309020205020404" pitchFamily="49" charset="0"/>
-              </a:rPr>
-              <a:t>"</a:t>
-            </a:r>
+              <a:t>stop-mode="stop-when-button-pressed"</a:t>
+            </a:r>
+            <a:endParaRPr lang="en-DK" sz="2835" dirty="0">
+              <a:latin typeface="Courier New" panose="02070309020205020404" pitchFamily="49" charset="0"/>
+              <a:cs typeface="Courier New" panose="02070309020205020404" pitchFamily="49" charset="0"/>
+            </a:endParaRPr>
           </a:p>
         </p:txBody>
       </p:sp>
@@ -6858,7 +7256,7 @@
           <p:cNvPr id="12" name="Picture 11">
             <a:extLst>
               <a:ext uri="{FF2B5EF4-FFF2-40B4-BE49-F238E27FC236}">
-                <a16:creationId xmlns:a16="http://schemas.microsoft.com/office/drawing/2014/main" id="{C8CE9036-5963-7EAA-B42D-BC11D1F6FFC5}"/>
+                <a16:creationId xmlns:a16="http://schemas.microsoft.com/office/drawing/2014/main" id="{33D1277F-E94A-28F1-0FF5-AC329DE5B42E}"/>
               </a:ext>
             </a:extLst>
           </p:cNvPr>
@@ -6875,8 +7273,8 @@
         </p:blipFill>
         <p:spPr>
           <a:xfrm>
-            <a:off x="2108723" y="7503334"/>
-            <a:ext cx="8929594" cy="5404754"/>
+            <a:off x="2108723" y="6740964"/>
+            <a:ext cx="8929594" cy="5382598"/>
           </a:xfrm>
           <a:prstGeom prst="rect">
             <a:avLst/>
@@ -6888,7 +7286,7 @@
           <p:cNvPr id="13" name="Picture 12">
             <a:extLst>
               <a:ext uri="{FF2B5EF4-FFF2-40B4-BE49-F238E27FC236}">
-                <a16:creationId xmlns:a16="http://schemas.microsoft.com/office/drawing/2014/main" id="{2124CACD-5100-48E3-A0FD-64500311B7DF}"/>
+                <a16:creationId xmlns:a16="http://schemas.microsoft.com/office/drawing/2014/main" id="{DA301C8C-A304-8116-D67C-E3B697A0A009}"/>
               </a:ext>
             </a:extLst>
           </p:cNvPr>
@@ -6905,8 +7303,8 @@
         </p:blipFill>
         <p:spPr>
           <a:xfrm>
-            <a:off x="11038317" y="7491987"/>
-            <a:ext cx="8929594" cy="5382598"/>
+            <a:off x="10800556" y="6757488"/>
+            <a:ext cx="8929594" cy="5352251"/>
           </a:xfrm>
           <a:prstGeom prst="rect">
             <a:avLst/>
@@ -6916,261 +7314,7 @@
     </p:spTree>
     <p:extLst>
       <p:ext uri="{BB962C8B-B14F-4D97-AF65-F5344CB8AC3E}">
-        <p14:creationId xmlns:p14="http://schemas.microsoft.com/office/powerpoint/2010/main" val="1687520235"/>
-      </p:ext>
-    </p:extLst>
-  </p:cSld>
-  <p:clrMapOvr>
-    <a:masterClrMapping/>
-  </p:clrMapOvr>
-</p:sld>
-</file>
-
-<file path=ppt/slides/slide12.xml><?xml version="1.0" encoding="utf-8"?>
-<p:sld xmlns:a="http://schemas.openxmlformats.org/drawingml/2006/main" xmlns:r="http://schemas.openxmlformats.org/officeDocument/2006/relationships" xmlns:p="http://schemas.openxmlformats.org/presentationml/2006/main">
-  <p:cSld>
-    <p:spTree>
-      <p:nvGrpSpPr>
-        <p:cNvPr id="1" name="">
-          <a:extLst>
-            <a:ext uri="{FF2B5EF4-FFF2-40B4-BE49-F238E27FC236}">
-              <a16:creationId xmlns:a16="http://schemas.microsoft.com/office/drawing/2014/main" id="{9EA41E8A-702A-C812-BBEA-B0FE61E869F3}"/>
-            </a:ext>
-          </a:extLst>
-        </p:cNvPr>
-        <p:cNvGrpSpPr/>
-        <p:nvPr/>
-      </p:nvGrpSpPr>
-      <p:grpSpPr>
-        <a:xfrm>
-          <a:off x="0" y="0"/>
-          <a:ext cx="0" cy="0"/>
-          <a:chOff x="0" y="0"/>
-          <a:chExt cx="0" cy="0"/>
-        </a:xfrm>
-      </p:grpSpPr>
-      <p:sp>
-        <p:nvSpPr>
-          <p:cNvPr id="4" name="TextBox 3">
-            <a:extLst>
-              <a:ext uri="{FF2B5EF4-FFF2-40B4-BE49-F238E27FC236}">
-                <a16:creationId xmlns:a16="http://schemas.microsoft.com/office/drawing/2014/main" id="{8A32358C-FBC6-BAF8-8092-1C8DCD637B70}"/>
-              </a:ext>
-            </a:extLst>
-          </p:cNvPr>
-          <p:cNvSpPr txBox="1"/>
-          <p:nvPr/>
-        </p:nvSpPr>
-        <p:spPr>
-          <a:xfrm>
-            <a:off x="2108723" y="3303097"/>
-            <a:ext cx="466794" cy="637547"/>
-          </a:xfrm>
-          <a:prstGeom prst="rect">
-            <a:avLst/>
-          </a:prstGeom>
-          <a:noFill/>
-        </p:spPr>
-        <p:txBody>
-          <a:bodyPr wrap="none" rtlCol="0">
-            <a:spAutoFit/>
-          </a:bodyPr>
-          <a:lstStyle/>
-          <a:p>
-            <a:r>
-              <a:rPr lang="en-GB" sz="3543" b="1" dirty="0"/>
-              <a:t>A</a:t>
-            </a:r>
-            <a:endParaRPr lang="en-DK" sz="3543" b="1" dirty="0"/>
-          </a:p>
-        </p:txBody>
-      </p:sp>
-      <p:sp>
-        <p:nvSpPr>
-          <p:cNvPr id="5" name="TextBox 4">
-            <a:extLst>
-              <a:ext uri="{FF2B5EF4-FFF2-40B4-BE49-F238E27FC236}">
-                <a16:creationId xmlns:a16="http://schemas.microsoft.com/office/drawing/2014/main" id="{5FAD2A63-A019-9CE3-AB08-AE5EB0C62E5E}"/>
-              </a:ext>
-            </a:extLst>
-          </p:cNvPr>
-          <p:cNvSpPr txBox="1"/>
-          <p:nvPr/>
-        </p:nvSpPr>
-        <p:spPr>
-          <a:xfrm>
-            <a:off x="11038317" y="3303097"/>
-            <a:ext cx="465192" cy="637547"/>
-          </a:xfrm>
-          <a:prstGeom prst="rect">
-            <a:avLst/>
-          </a:prstGeom>
-          <a:noFill/>
-        </p:spPr>
-        <p:txBody>
-          <a:bodyPr wrap="none" rtlCol="0">
-            <a:spAutoFit/>
-          </a:bodyPr>
-          <a:lstStyle/>
-          <a:p>
-            <a:r>
-              <a:rPr lang="en-GB" sz="3543" b="1" dirty="0"/>
-              <a:t>B</a:t>
-            </a:r>
-            <a:endParaRPr lang="en-DK" sz="3543" b="1" dirty="0"/>
-          </a:p>
-        </p:txBody>
-      </p:sp>
-      <p:sp>
-        <p:nvSpPr>
-          <p:cNvPr id="6" name="TextBox 5">
-            <a:extLst>
-              <a:ext uri="{FF2B5EF4-FFF2-40B4-BE49-F238E27FC236}">
-                <a16:creationId xmlns:a16="http://schemas.microsoft.com/office/drawing/2014/main" id="{C20292EC-BA8A-1248-EF67-3446775989E1}"/>
-              </a:ext>
-            </a:extLst>
-          </p:cNvPr>
-          <p:cNvSpPr txBox="1"/>
-          <p:nvPr/>
-        </p:nvSpPr>
-        <p:spPr>
-          <a:xfrm>
-            <a:off x="2717077" y="9464497"/>
-            <a:ext cx="8083479" cy="528606"/>
-          </a:xfrm>
-          <a:prstGeom prst="rect">
-            <a:avLst/>
-          </a:prstGeom>
-          <a:noFill/>
-        </p:spPr>
-        <p:txBody>
-          <a:bodyPr wrap="square">
-            <a:spAutoFit/>
-          </a:bodyPr>
-          <a:lstStyle/>
-          <a:p>
-            <a:pPr algn="ctr"/>
-            <a:r>
-              <a:rPr lang="en-GB" sz="2835" dirty="0">
-                <a:latin typeface="Courier New" panose="02070309020205020404" pitchFamily="49" charset="0"/>
-                <a:cs typeface="Courier New" panose="02070309020205020404" pitchFamily="49" charset="0"/>
-              </a:rPr>
-              <a:t>stop-mode="stop-on-maximal-rating"</a:t>
-            </a:r>
-            <a:endParaRPr lang="en-DK" sz="2835" dirty="0">
-              <a:latin typeface="Courier New" panose="02070309020205020404" pitchFamily="49" charset="0"/>
-              <a:cs typeface="Courier New" panose="02070309020205020404" pitchFamily="49" charset="0"/>
-            </a:endParaRPr>
-          </a:p>
-        </p:txBody>
-      </p:sp>
-      <p:sp>
-        <p:nvSpPr>
-          <p:cNvPr id="7" name="TextBox 6">
-            <a:extLst>
-              <a:ext uri="{FF2B5EF4-FFF2-40B4-BE49-F238E27FC236}">
-                <a16:creationId xmlns:a16="http://schemas.microsoft.com/office/drawing/2014/main" id="{9691AA1E-6883-E41C-B5E1-5BF14A75740A}"/>
-              </a:ext>
-            </a:extLst>
-          </p:cNvPr>
-          <p:cNvSpPr txBox="1"/>
-          <p:nvPr/>
-        </p:nvSpPr>
-        <p:spPr>
-          <a:xfrm>
-            <a:off x="11646671" y="9464497"/>
-            <a:ext cx="8321240" cy="528606"/>
-          </a:xfrm>
-          <a:prstGeom prst="rect">
-            <a:avLst/>
-          </a:prstGeom>
-          <a:noFill/>
-        </p:spPr>
-        <p:txBody>
-          <a:bodyPr wrap="square">
-            <a:spAutoFit/>
-          </a:bodyPr>
-          <a:lstStyle/>
-          <a:p>
-            <a:pPr algn="ctr"/>
-            <a:r>
-              <a:rPr lang="en-GB" sz="2835" dirty="0">
-                <a:latin typeface="Courier New" panose="02070309020205020404" pitchFamily="49" charset="0"/>
-                <a:cs typeface="Courier New" panose="02070309020205020404" pitchFamily="49" charset="0"/>
-              </a:rPr>
-              <a:t>stop-mode="stop-when-button-pressed"</a:t>
-            </a:r>
-            <a:endParaRPr lang="en-DK" sz="2835" dirty="0">
-              <a:latin typeface="Courier New" panose="02070309020205020404" pitchFamily="49" charset="0"/>
-              <a:cs typeface="Courier New" panose="02070309020205020404" pitchFamily="49" charset="0"/>
-            </a:endParaRPr>
-          </a:p>
-        </p:txBody>
-      </p:sp>
-      <p:pic>
-        <p:nvPicPr>
-          <p:cNvPr id="8" name="Picture 7">
-            <a:extLst>
-              <a:ext uri="{FF2B5EF4-FFF2-40B4-BE49-F238E27FC236}">
-                <a16:creationId xmlns:a16="http://schemas.microsoft.com/office/drawing/2014/main" id="{33D1277F-E94A-28F1-0FF5-AC329DE5B42E}"/>
-              </a:ext>
-            </a:extLst>
-          </p:cNvPr>
-          <p:cNvPicPr>
-            <a:picLocks noChangeAspect="1"/>
-          </p:cNvPicPr>
-          <p:nvPr/>
-        </p:nvPicPr>
-        <p:blipFill>
-          <a:blip r:embed="rId3"/>
-          <a:stretch>
-            <a:fillRect/>
-          </a:stretch>
-        </p:blipFill>
-        <p:spPr>
-          <a:xfrm>
-            <a:off x="2108723" y="3956203"/>
-            <a:ext cx="8929594" cy="5382598"/>
-          </a:xfrm>
-          <a:prstGeom prst="rect">
-            <a:avLst/>
-          </a:prstGeom>
-        </p:spPr>
-      </p:pic>
-      <p:pic>
-        <p:nvPicPr>
-          <p:cNvPr id="11" name="Picture 10">
-            <a:extLst>
-              <a:ext uri="{FF2B5EF4-FFF2-40B4-BE49-F238E27FC236}">
-                <a16:creationId xmlns:a16="http://schemas.microsoft.com/office/drawing/2014/main" id="{DA301C8C-A304-8116-D67C-E3B697A0A009}"/>
-              </a:ext>
-            </a:extLst>
-          </p:cNvPr>
-          <p:cNvPicPr>
-            <a:picLocks noChangeAspect="1"/>
-          </p:cNvPicPr>
-          <p:nvPr/>
-        </p:nvPicPr>
-        <p:blipFill>
-          <a:blip r:embed="rId4"/>
-          <a:stretch>
-            <a:fillRect/>
-          </a:stretch>
-        </p:blipFill>
-        <p:spPr>
-          <a:xfrm>
-            <a:off x="10800556" y="3972727"/>
-            <a:ext cx="8929594" cy="5352251"/>
-          </a:xfrm>
-          <a:prstGeom prst="rect">
-            <a:avLst/>
-          </a:prstGeom>
-        </p:spPr>
-      </p:pic>
-    </p:spTree>
-    <p:extLst>
-      <p:ext uri="{BB962C8B-B14F-4D97-AF65-F5344CB8AC3E}">
-        <p14:creationId xmlns:p14="http://schemas.microsoft.com/office/powerpoint/2010/main" val="3880552031"/>
+        <p14:creationId xmlns:p14="http://schemas.microsoft.com/office/powerpoint/2010/main" val="254473305"/>
       </p:ext>
     </p:extLst>
   </p:cSld>
@@ -7534,904 +7678,6 @@
     <p:extLst>
       <p:ext uri="{BB962C8B-B14F-4D97-AF65-F5344CB8AC3E}">
         <p14:creationId xmlns:p14="http://schemas.microsoft.com/office/powerpoint/2010/main" val="292422105"/>
-      </p:ext>
-    </p:extLst>
-  </p:cSld>
-  <p:clrMapOvr>
-    <a:masterClrMapping/>
-  </p:clrMapOvr>
-</p:sld>
-</file>
-
-<file path=ppt/slides/slide14.xml><?xml version="1.0" encoding="utf-8"?>
-<p:sld xmlns:a="http://schemas.openxmlformats.org/drawingml/2006/main" xmlns:r="http://schemas.openxmlformats.org/officeDocument/2006/relationships" xmlns:p="http://schemas.openxmlformats.org/presentationml/2006/main">
-  <p:cSld>
-    <p:spTree>
-      <p:nvGrpSpPr>
-        <p:cNvPr id="1" name="">
-          <a:extLst>
-            <a:ext uri="{FF2B5EF4-FFF2-40B4-BE49-F238E27FC236}">
-              <a16:creationId xmlns:a16="http://schemas.microsoft.com/office/drawing/2014/main" id="{3AC95BBF-3A2E-AAAD-B35F-E7DB8CC69D87}"/>
-            </a:ext>
-          </a:extLst>
-        </p:cNvPr>
-        <p:cNvGrpSpPr/>
-        <p:nvPr/>
-      </p:nvGrpSpPr>
-      <p:grpSpPr>
-        <a:xfrm>
-          <a:off x="0" y="0"/>
-          <a:ext cx="0" cy="0"/>
-          <a:chOff x="0" y="0"/>
-          <a:chExt cx="0" cy="0"/>
-        </a:xfrm>
-      </p:grpSpPr>
-      <p:sp>
-        <p:nvSpPr>
-          <p:cNvPr id="6" name="TextBox 5">
-            <a:extLst>
-              <a:ext uri="{FF2B5EF4-FFF2-40B4-BE49-F238E27FC236}">
-                <a16:creationId xmlns:a16="http://schemas.microsoft.com/office/drawing/2014/main" id="{1498AA88-A732-B481-B639-C4A6332621C6}"/>
-              </a:ext>
-            </a:extLst>
-          </p:cNvPr>
-          <p:cNvSpPr txBox="1"/>
-          <p:nvPr/>
-        </p:nvSpPr>
-        <p:spPr>
-          <a:xfrm>
-            <a:off x="2108723" y="7189297"/>
-            <a:ext cx="505267" cy="637547"/>
-          </a:xfrm>
-          <a:prstGeom prst="rect">
-            <a:avLst/>
-          </a:prstGeom>
-          <a:noFill/>
-        </p:spPr>
-        <p:txBody>
-          <a:bodyPr wrap="none" rtlCol="0">
-            <a:spAutoFit/>
-          </a:bodyPr>
-          <a:lstStyle/>
-          <a:p>
-            <a:r>
-              <a:rPr lang="en-US" sz="3543" b="1" dirty="0"/>
-              <a:t>C</a:t>
-            </a:r>
-            <a:endParaRPr lang="en-DK" sz="3543" b="1" dirty="0"/>
-          </a:p>
-        </p:txBody>
-      </p:sp>
-      <p:sp>
-        <p:nvSpPr>
-          <p:cNvPr id="7" name="TextBox 6">
-            <a:extLst>
-              <a:ext uri="{FF2B5EF4-FFF2-40B4-BE49-F238E27FC236}">
-                <a16:creationId xmlns:a16="http://schemas.microsoft.com/office/drawing/2014/main" id="{F866BA5C-02B5-D7ED-6829-E0ECF040144E}"/>
-              </a:ext>
-            </a:extLst>
-          </p:cNvPr>
-          <p:cNvSpPr txBox="1"/>
-          <p:nvPr/>
-        </p:nvSpPr>
-        <p:spPr>
-          <a:xfrm>
-            <a:off x="11038317" y="7189297"/>
-            <a:ext cx="505267" cy="637547"/>
-          </a:xfrm>
-          <a:prstGeom prst="rect">
-            <a:avLst/>
-          </a:prstGeom>
-          <a:noFill/>
-        </p:spPr>
-        <p:txBody>
-          <a:bodyPr wrap="none" rtlCol="0">
-            <a:spAutoFit/>
-          </a:bodyPr>
-          <a:lstStyle/>
-          <a:p>
-            <a:r>
-              <a:rPr lang="en-US" sz="3543" b="1" dirty="0"/>
-              <a:t>D</a:t>
-            </a:r>
-            <a:endParaRPr lang="en-DK" sz="3543" b="1" dirty="0"/>
-          </a:p>
-        </p:txBody>
-      </p:sp>
-      <p:sp>
-        <p:nvSpPr>
-          <p:cNvPr id="9" name="TextBox 8">
-            <a:extLst>
-              <a:ext uri="{FF2B5EF4-FFF2-40B4-BE49-F238E27FC236}">
-                <a16:creationId xmlns:a16="http://schemas.microsoft.com/office/drawing/2014/main" id="{C9C8CF11-AAF0-2AAB-D57E-8B266E016715}"/>
-              </a:ext>
-            </a:extLst>
-          </p:cNvPr>
-          <p:cNvSpPr txBox="1"/>
-          <p:nvPr/>
-        </p:nvSpPr>
-        <p:spPr>
-          <a:xfrm>
-            <a:off x="2717077" y="13350697"/>
-            <a:ext cx="8083479" cy="528606"/>
-          </a:xfrm>
-          <a:prstGeom prst="rect">
-            <a:avLst/>
-          </a:prstGeom>
-          <a:noFill/>
-        </p:spPr>
-        <p:txBody>
-          <a:bodyPr wrap="square">
-            <a:spAutoFit/>
-          </a:bodyPr>
-          <a:lstStyle/>
-          <a:p>
-            <a:pPr algn="ctr"/>
-            <a:r>
-              <a:rPr lang="en-GB" sz="2835" dirty="0">
-                <a:latin typeface="Courier New" panose="02070309020205020404" pitchFamily="49" charset="0"/>
-                <a:cs typeface="Courier New" panose="02070309020205020404" pitchFamily="49" charset="0"/>
-              </a:rPr>
-              <a:t>conditioning-time="0"</a:t>
-            </a:r>
-            <a:endParaRPr lang="en-DK" sz="2835" dirty="0">
-              <a:latin typeface="Courier New" panose="02070309020205020404" pitchFamily="49" charset="0"/>
-              <a:cs typeface="Courier New" panose="02070309020205020404" pitchFamily="49" charset="0"/>
-            </a:endParaRPr>
-          </a:p>
-        </p:txBody>
-      </p:sp>
-      <p:sp>
-        <p:nvSpPr>
-          <p:cNvPr id="11" name="TextBox 10">
-            <a:extLst>
-              <a:ext uri="{FF2B5EF4-FFF2-40B4-BE49-F238E27FC236}">
-                <a16:creationId xmlns:a16="http://schemas.microsoft.com/office/drawing/2014/main" id="{C7F2DE6A-6845-AA6A-E397-22E1B2646235}"/>
-              </a:ext>
-            </a:extLst>
-          </p:cNvPr>
-          <p:cNvSpPr txBox="1"/>
-          <p:nvPr/>
-        </p:nvSpPr>
-        <p:spPr>
-          <a:xfrm>
-            <a:off x="11646671" y="13350697"/>
-            <a:ext cx="8321240" cy="528606"/>
-          </a:xfrm>
-          <a:prstGeom prst="rect">
-            <a:avLst/>
-          </a:prstGeom>
-          <a:noFill/>
-        </p:spPr>
-        <p:txBody>
-          <a:bodyPr wrap="square">
-            <a:spAutoFit/>
-          </a:bodyPr>
-          <a:lstStyle/>
-          <a:p>
-            <a:pPr algn="ctr"/>
-            <a:r>
-              <a:rPr lang="en-GB" sz="2835" dirty="0">
-                <a:latin typeface="Courier New" panose="02070309020205020404" pitchFamily="49" charset="0"/>
-                <a:cs typeface="Courier New" panose="02070309020205020404" pitchFamily="49" charset="0"/>
-              </a:rPr>
-              <a:t>conditioning-time="30"</a:t>
-            </a:r>
-            <a:endParaRPr lang="en-DK" sz="2835" dirty="0">
-              <a:latin typeface="Courier New" panose="02070309020205020404" pitchFamily="49" charset="0"/>
-              <a:cs typeface="Courier New" panose="02070309020205020404" pitchFamily="49" charset="0"/>
-            </a:endParaRPr>
-          </a:p>
-        </p:txBody>
-      </p:sp>
-      <p:pic>
-        <p:nvPicPr>
-          <p:cNvPr id="4" name="Picture 3">
-            <a:extLst>
-              <a:ext uri="{FF2B5EF4-FFF2-40B4-BE49-F238E27FC236}">
-                <a16:creationId xmlns:a16="http://schemas.microsoft.com/office/drawing/2014/main" id="{AA4B8445-130E-1905-2273-AB9078F22D1B}"/>
-              </a:ext>
-            </a:extLst>
-          </p:cNvPr>
-          <p:cNvPicPr>
-            <a:picLocks noChangeAspect="1"/>
-          </p:cNvPicPr>
-          <p:nvPr/>
-        </p:nvPicPr>
-        <p:blipFill>
-          <a:blip r:embed="rId3"/>
-          <a:stretch>
-            <a:fillRect/>
-          </a:stretch>
-        </p:blipFill>
-        <p:spPr>
-          <a:xfrm>
-            <a:off x="11038317" y="7861369"/>
-            <a:ext cx="8929594" cy="5349461"/>
-          </a:xfrm>
-          <a:prstGeom prst="rect">
-            <a:avLst/>
-          </a:prstGeom>
-        </p:spPr>
-      </p:pic>
-      <p:pic>
-        <p:nvPicPr>
-          <p:cNvPr id="10" name="Picture 9">
-            <a:extLst>
-              <a:ext uri="{FF2B5EF4-FFF2-40B4-BE49-F238E27FC236}">
-                <a16:creationId xmlns:a16="http://schemas.microsoft.com/office/drawing/2014/main" id="{0E012E38-2495-21AE-17DD-1BB208508BB5}"/>
-              </a:ext>
-            </a:extLst>
-          </p:cNvPr>
-          <p:cNvPicPr>
-            <a:picLocks noChangeAspect="1"/>
-          </p:cNvPicPr>
-          <p:nvPr/>
-        </p:nvPicPr>
-        <p:blipFill>
-          <a:blip r:embed="rId4"/>
-          <a:stretch>
-            <a:fillRect/>
-          </a:stretch>
-        </p:blipFill>
-        <p:spPr>
-          <a:xfrm>
-            <a:off x="1845669" y="7861370"/>
-            <a:ext cx="8929594" cy="5308376"/>
-          </a:xfrm>
-          <a:prstGeom prst="rect">
-            <a:avLst/>
-          </a:prstGeom>
-        </p:spPr>
-      </p:pic>
-      <p:sp>
-        <p:nvSpPr>
-          <p:cNvPr id="2" name="TextBox 1">
-            <a:extLst>
-              <a:ext uri="{FF2B5EF4-FFF2-40B4-BE49-F238E27FC236}">
-                <a16:creationId xmlns:a16="http://schemas.microsoft.com/office/drawing/2014/main" id="{C3B61B95-81C1-C5CB-2179-851C49B0E187}"/>
-              </a:ext>
-            </a:extLst>
-          </p:cNvPr>
-          <p:cNvSpPr txBox="1"/>
-          <p:nvPr/>
-        </p:nvSpPr>
-        <p:spPr>
-          <a:xfrm>
-            <a:off x="2108723" y="871621"/>
-            <a:ext cx="466794" cy="637547"/>
-          </a:xfrm>
-          <a:prstGeom prst="rect">
-            <a:avLst/>
-          </a:prstGeom>
-          <a:noFill/>
-        </p:spPr>
-        <p:txBody>
-          <a:bodyPr wrap="none" rtlCol="0">
-            <a:spAutoFit/>
-          </a:bodyPr>
-          <a:lstStyle/>
-          <a:p>
-            <a:r>
-              <a:rPr lang="en-GB" sz="3543" b="1" dirty="0"/>
-              <a:t>A</a:t>
-            </a:r>
-            <a:endParaRPr lang="en-DK" sz="3543" b="1" dirty="0"/>
-          </a:p>
-        </p:txBody>
-      </p:sp>
-      <p:sp>
-        <p:nvSpPr>
-          <p:cNvPr id="3" name="TextBox 2">
-            <a:extLst>
-              <a:ext uri="{FF2B5EF4-FFF2-40B4-BE49-F238E27FC236}">
-                <a16:creationId xmlns:a16="http://schemas.microsoft.com/office/drawing/2014/main" id="{2877030B-42EF-9DC1-CD27-5A20AB02E0FB}"/>
-              </a:ext>
-            </a:extLst>
-          </p:cNvPr>
-          <p:cNvSpPr txBox="1"/>
-          <p:nvPr/>
-        </p:nvSpPr>
-        <p:spPr>
-          <a:xfrm>
-            <a:off x="11038317" y="871621"/>
-            <a:ext cx="465192" cy="637547"/>
-          </a:xfrm>
-          <a:prstGeom prst="rect">
-            <a:avLst/>
-          </a:prstGeom>
-          <a:noFill/>
-        </p:spPr>
-        <p:txBody>
-          <a:bodyPr wrap="none" rtlCol="0">
-            <a:spAutoFit/>
-          </a:bodyPr>
-          <a:lstStyle/>
-          <a:p>
-            <a:r>
-              <a:rPr lang="en-GB" sz="3543" b="1" dirty="0"/>
-              <a:t>B</a:t>
-            </a:r>
-            <a:endParaRPr lang="en-DK" sz="3543" b="1" dirty="0"/>
-          </a:p>
-        </p:txBody>
-      </p:sp>
-      <p:pic>
-        <p:nvPicPr>
-          <p:cNvPr id="12" name="Picture 11">
-            <a:extLst>
-              <a:ext uri="{FF2B5EF4-FFF2-40B4-BE49-F238E27FC236}">
-                <a16:creationId xmlns:a16="http://schemas.microsoft.com/office/drawing/2014/main" id="{7A34434A-D1E7-E22E-CB04-B22F11CE1717}"/>
-              </a:ext>
-            </a:extLst>
-          </p:cNvPr>
-          <p:cNvPicPr>
-            <a:picLocks noChangeAspect="1"/>
-          </p:cNvPicPr>
-          <p:nvPr/>
-        </p:nvPicPr>
-        <p:blipFill>
-          <a:blip r:embed="rId5"/>
-          <a:stretch>
-            <a:fillRect/>
-          </a:stretch>
-        </p:blipFill>
-        <p:spPr>
-          <a:xfrm>
-            <a:off x="2108723" y="1527545"/>
-            <a:ext cx="8929594" cy="5418577"/>
-          </a:xfrm>
-          <a:prstGeom prst="rect">
-            <a:avLst/>
-          </a:prstGeom>
-        </p:spPr>
-      </p:pic>
-      <p:pic>
-        <p:nvPicPr>
-          <p:cNvPr id="13" name="Picture 12">
-            <a:extLst>
-              <a:ext uri="{FF2B5EF4-FFF2-40B4-BE49-F238E27FC236}">
-                <a16:creationId xmlns:a16="http://schemas.microsoft.com/office/drawing/2014/main" id="{FD3696A5-C8FE-95A2-B3A6-7A3793670D7B}"/>
-              </a:ext>
-            </a:extLst>
-          </p:cNvPr>
-          <p:cNvPicPr>
-            <a:picLocks noChangeAspect="1"/>
-          </p:cNvPicPr>
-          <p:nvPr/>
-        </p:nvPicPr>
-        <p:blipFill>
-          <a:blip r:embed="rId6"/>
-          <a:stretch>
-            <a:fillRect/>
-          </a:stretch>
-        </p:blipFill>
-        <p:spPr>
-          <a:xfrm>
-            <a:off x="11038317" y="1527546"/>
-            <a:ext cx="8929594" cy="5385232"/>
-          </a:xfrm>
-          <a:prstGeom prst="rect">
-            <a:avLst/>
-          </a:prstGeom>
-        </p:spPr>
-      </p:pic>
-    </p:spTree>
-    <p:extLst>
-      <p:ext uri="{BB962C8B-B14F-4D97-AF65-F5344CB8AC3E}">
-        <p14:creationId xmlns:p14="http://schemas.microsoft.com/office/powerpoint/2010/main" val="967448938"/>
-      </p:ext>
-    </p:extLst>
-  </p:cSld>
-  <p:clrMapOvr>
-    <a:masterClrMapping/>
-  </p:clrMapOvr>
-</p:sld>
-</file>
-
-<file path=ppt/slides/slide15.xml><?xml version="1.0" encoding="utf-8"?>
-<p:sld xmlns:a="http://schemas.openxmlformats.org/drawingml/2006/main" xmlns:r="http://schemas.openxmlformats.org/officeDocument/2006/relationships" xmlns:p="http://schemas.openxmlformats.org/presentationml/2006/main">
-  <p:cSld>
-    <p:spTree>
-      <p:nvGrpSpPr>
-        <p:cNvPr id="1" name="">
-          <a:extLst>
-            <a:ext uri="{FF2B5EF4-FFF2-40B4-BE49-F238E27FC236}">
-              <a16:creationId xmlns:a16="http://schemas.microsoft.com/office/drawing/2014/main" id="{2A03C425-888E-886C-8702-9EF41C245D6C}"/>
-            </a:ext>
-          </a:extLst>
-        </p:cNvPr>
-        <p:cNvGrpSpPr/>
-        <p:nvPr/>
-      </p:nvGrpSpPr>
-      <p:grpSpPr>
-        <a:xfrm>
-          <a:off x="0" y="0"/>
-          <a:ext cx="0" cy="0"/>
-          <a:chOff x="0" y="0"/>
-          <a:chExt cx="0" cy="0"/>
-        </a:xfrm>
-      </p:grpSpPr>
-      <p:sp>
-        <p:nvSpPr>
-          <p:cNvPr id="2" name="TextBox 1">
-            <a:extLst>
-              <a:ext uri="{FF2B5EF4-FFF2-40B4-BE49-F238E27FC236}">
-                <a16:creationId xmlns:a16="http://schemas.microsoft.com/office/drawing/2014/main" id="{82FBC297-07B8-E259-3D99-65826BD07397}"/>
-              </a:ext>
-            </a:extLst>
-          </p:cNvPr>
-          <p:cNvSpPr txBox="1"/>
-          <p:nvPr/>
-        </p:nvSpPr>
-        <p:spPr>
-          <a:xfrm>
-            <a:off x="1870962" y="1124794"/>
-            <a:ext cx="466794" cy="637547"/>
-          </a:xfrm>
-          <a:prstGeom prst="rect">
-            <a:avLst/>
-          </a:prstGeom>
-          <a:noFill/>
-        </p:spPr>
-        <p:txBody>
-          <a:bodyPr wrap="none" rtlCol="0">
-            <a:spAutoFit/>
-          </a:bodyPr>
-          <a:lstStyle/>
-          <a:p>
-            <a:r>
-              <a:rPr lang="en-GB" sz="3543" b="1" dirty="0"/>
-              <a:t>A</a:t>
-            </a:r>
-            <a:endParaRPr lang="en-DK" sz="3543" b="1" dirty="0"/>
-          </a:p>
-        </p:txBody>
-      </p:sp>
-      <p:sp>
-        <p:nvSpPr>
-          <p:cNvPr id="3" name="TextBox 2">
-            <a:extLst>
-              <a:ext uri="{FF2B5EF4-FFF2-40B4-BE49-F238E27FC236}">
-                <a16:creationId xmlns:a16="http://schemas.microsoft.com/office/drawing/2014/main" id="{F0D45F0D-B877-1194-B331-39558D2629E0}"/>
-              </a:ext>
-            </a:extLst>
-          </p:cNvPr>
-          <p:cNvSpPr txBox="1"/>
-          <p:nvPr/>
-        </p:nvSpPr>
-        <p:spPr>
-          <a:xfrm>
-            <a:off x="10100968" y="1124794"/>
-            <a:ext cx="465192" cy="637547"/>
-          </a:xfrm>
-          <a:prstGeom prst="rect">
-            <a:avLst/>
-          </a:prstGeom>
-          <a:noFill/>
-        </p:spPr>
-        <p:txBody>
-          <a:bodyPr wrap="none" rtlCol="0">
-            <a:spAutoFit/>
-          </a:bodyPr>
-          <a:lstStyle/>
-          <a:p>
-            <a:r>
-              <a:rPr lang="en-GB" sz="3543" b="1" dirty="0"/>
-              <a:t>B</a:t>
-            </a:r>
-            <a:endParaRPr lang="en-DK" sz="3543" b="1" dirty="0"/>
-          </a:p>
-        </p:txBody>
-      </p:sp>
-      <p:sp>
-        <p:nvSpPr>
-          <p:cNvPr id="4" name="TextBox 3">
-            <a:extLst>
-              <a:ext uri="{FF2B5EF4-FFF2-40B4-BE49-F238E27FC236}">
-                <a16:creationId xmlns:a16="http://schemas.microsoft.com/office/drawing/2014/main" id="{73C6C390-8E6B-29EC-2644-9CDDC29CF81B}"/>
-              </a:ext>
-            </a:extLst>
-          </p:cNvPr>
-          <p:cNvSpPr txBox="1"/>
-          <p:nvPr/>
-        </p:nvSpPr>
-        <p:spPr>
-          <a:xfrm>
-            <a:off x="2175139" y="6318156"/>
-            <a:ext cx="8083479" cy="855619"/>
-          </a:xfrm>
-          <a:prstGeom prst="rect">
-            <a:avLst/>
-          </a:prstGeom>
-          <a:noFill/>
-        </p:spPr>
-        <p:txBody>
-          <a:bodyPr wrap="square">
-            <a:spAutoFit/>
-          </a:bodyPr>
-          <a:lstStyle/>
-          <a:p>
-            <a:pPr algn="ctr"/>
-            <a:r>
-              <a:rPr lang="en-GB" sz="2480" dirty="0">
-                <a:latin typeface="Courier New" panose="02070309020205020404" pitchFamily="49" charset="0"/>
-                <a:cs typeface="Courier New" panose="02070309020205020404" pitchFamily="49" charset="0"/>
-              </a:rPr>
-              <a:t>delta-conditional-pressure="10“</a:t>
-            </a:r>
-          </a:p>
-          <a:p>
-            <a:pPr algn="ctr"/>
-            <a:r>
-              <a:rPr lang="en-GB" sz="2480" dirty="0">
-                <a:latin typeface="Courier New" panose="02070309020205020404" pitchFamily="49" charset="0"/>
-                <a:cs typeface="Courier New" panose="02070309020205020404" pitchFamily="49" charset="0"/>
-              </a:rPr>
-              <a:t>conditioning-time="0"</a:t>
-            </a:r>
-            <a:endParaRPr lang="en-DK" sz="2480" dirty="0">
-              <a:latin typeface="Courier New" panose="02070309020205020404" pitchFamily="49" charset="0"/>
-              <a:cs typeface="Courier New" panose="02070309020205020404" pitchFamily="49" charset="0"/>
-            </a:endParaRPr>
-          </a:p>
-        </p:txBody>
-      </p:sp>
-      <p:sp>
-        <p:nvSpPr>
-          <p:cNvPr id="5" name="TextBox 4">
-            <a:extLst>
-              <a:ext uri="{FF2B5EF4-FFF2-40B4-BE49-F238E27FC236}">
-                <a16:creationId xmlns:a16="http://schemas.microsoft.com/office/drawing/2014/main" id="{31744852-A411-5FFE-EB0C-452B3DDC5239}"/>
-              </a:ext>
-            </a:extLst>
-          </p:cNvPr>
-          <p:cNvSpPr txBox="1"/>
-          <p:nvPr/>
-        </p:nvSpPr>
-        <p:spPr>
-          <a:xfrm>
-            <a:off x="9863208" y="6318156"/>
-            <a:ext cx="8321240" cy="855619"/>
-          </a:xfrm>
-          <a:prstGeom prst="rect">
-            <a:avLst/>
-          </a:prstGeom>
-          <a:noFill/>
-        </p:spPr>
-        <p:txBody>
-          <a:bodyPr wrap="square">
-            <a:spAutoFit/>
-          </a:bodyPr>
-          <a:lstStyle/>
-          <a:p>
-            <a:pPr algn="ctr"/>
-            <a:r>
-              <a:rPr lang="en-GB" sz="2480" dirty="0">
-                <a:latin typeface="Courier New" panose="02070309020205020404" pitchFamily="49" charset="0"/>
-                <a:cs typeface="Courier New" panose="02070309020205020404" pitchFamily="49" charset="0"/>
-              </a:rPr>
-              <a:t>delta-conditional-pressure="10“</a:t>
-            </a:r>
-          </a:p>
-          <a:p>
-            <a:pPr algn="ctr"/>
-            <a:r>
-              <a:rPr lang="en-GB" sz="2480" dirty="0">
-                <a:latin typeface="Courier New" panose="02070309020205020404" pitchFamily="49" charset="0"/>
-                <a:cs typeface="Courier New" panose="02070309020205020404" pitchFamily="49" charset="0"/>
-              </a:rPr>
-              <a:t>conditioning-time="30"</a:t>
-            </a:r>
-            <a:endParaRPr lang="en-DK" sz="2480" dirty="0">
-              <a:latin typeface="Courier New" panose="02070309020205020404" pitchFamily="49" charset="0"/>
-              <a:cs typeface="Courier New" panose="02070309020205020404" pitchFamily="49" charset="0"/>
-            </a:endParaRPr>
-          </a:p>
-        </p:txBody>
-      </p:sp>
-      <p:sp>
-        <p:nvSpPr>
-          <p:cNvPr id="8" name="TextBox 7">
-            <a:extLst>
-              <a:ext uri="{FF2B5EF4-FFF2-40B4-BE49-F238E27FC236}">
-                <a16:creationId xmlns:a16="http://schemas.microsoft.com/office/drawing/2014/main" id="{2ADC7E39-8E73-54E3-188D-789DB8AB33F2}"/>
-              </a:ext>
-            </a:extLst>
-          </p:cNvPr>
-          <p:cNvSpPr txBox="1"/>
-          <p:nvPr/>
-        </p:nvSpPr>
-        <p:spPr>
-          <a:xfrm>
-            <a:off x="1870963" y="6789119"/>
-            <a:ext cx="505267" cy="637547"/>
-          </a:xfrm>
-          <a:prstGeom prst="rect">
-            <a:avLst/>
-          </a:prstGeom>
-          <a:noFill/>
-        </p:spPr>
-        <p:txBody>
-          <a:bodyPr wrap="none" rtlCol="0">
-            <a:spAutoFit/>
-          </a:bodyPr>
-          <a:lstStyle/>
-          <a:p>
-            <a:r>
-              <a:rPr lang="en-GB" sz="3543" b="1" dirty="0"/>
-              <a:t>C</a:t>
-            </a:r>
-            <a:endParaRPr lang="en-DK" sz="3543" b="1" dirty="0"/>
-          </a:p>
-        </p:txBody>
-      </p:sp>
-      <p:sp>
-        <p:nvSpPr>
-          <p:cNvPr id="9" name="TextBox 8">
-            <a:extLst>
-              <a:ext uri="{FF2B5EF4-FFF2-40B4-BE49-F238E27FC236}">
-                <a16:creationId xmlns:a16="http://schemas.microsoft.com/office/drawing/2014/main" id="{79742922-EDD3-4273-98A4-7FB1FD5782ED}"/>
-              </a:ext>
-            </a:extLst>
-          </p:cNvPr>
-          <p:cNvSpPr txBox="1"/>
-          <p:nvPr/>
-        </p:nvSpPr>
-        <p:spPr>
-          <a:xfrm>
-            <a:off x="10100969" y="6789119"/>
-            <a:ext cx="505267" cy="637547"/>
-          </a:xfrm>
-          <a:prstGeom prst="rect">
-            <a:avLst/>
-          </a:prstGeom>
-          <a:noFill/>
-        </p:spPr>
-        <p:txBody>
-          <a:bodyPr wrap="none" rtlCol="0">
-            <a:spAutoFit/>
-          </a:bodyPr>
-          <a:lstStyle/>
-          <a:p>
-            <a:r>
-              <a:rPr lang="en-GB" sz="3543" b="1" dirty="0"/>
-              <a:t>D</a:t>
-            </a:r>
-            <a:endParaRPr lang="en-DK" sz="3543" b="1" dirty="0"/>
-          </a:p>
-        </p:txBody>
-      </p:sp>
-      <p:sp>
-        <p:nvSpPr>
-          <p:cNvPr id="10" name="TextBox 9">
-            <a:extLst>
-              <a:ext uri="{FF2B5EF4-FFF2-40B4-BE49-F238E27FC236}">
-                <a16:creationId xmlns:a16="http://schemas.microsoft.com/office/drawing/2014/main" id="{26C72CE9-F630-D917-764B-BC15F8330FF7}"/>
-              </a:ext>
-            </a:extLst>
-          </p:cNvPr>
-          <p:cNvSpPr txBox="1"/>
-          <p:nvPr/>
-        </p:nvSpPr>
-        <p:spPr>
-          <a:xfrm>
-            <a:off x="2175139" y="11960656"/>
-            <a:ext cx="8083479" cy="855619"/>
-          </a:xfrm>
-          <a:prstGeom prst="rect">
-            <a:avLst/>
-          </a:prstGeom>
-          <a:noFill/>
-        </p:spPr>
-        <p:txBody>
-          <a:bodyPr wrap="square">
-            <a:spAutoFit/>
-          </a:bodyPr>
-          <a:lstStyle/>
-          <a:p>
-            <a:pPr algn="ctr"/>
-            <a:r>
-              <a:rPr lang="en-GB" sz="2480" dirty="0">
-                <a:latin typeface="Courier New" panose="02070309020205020404" pitchFamily="49" charset="0"/>
-                <a:cs typeface="Courier New" panose="02070309020205020404" pitchFamily="49" charset="0"/>
-              </a:rPr>
-              <a:t>delta-conditional-pressure="0“</a:t>
-            </a:r>
-          </a:p>
-          <a:p>
-            <a:pPr algn="ctr"/>
-            <a:r>
-              <a:rPr lang="en-GB" sz="2480" dirty="0">
-                <a:latin typeface="Courier New" panose="02070309020205020404" pitchFamily="49" charset="0"/>
-                <a:cs typeface="Courier New" panose="02070309020205020404" pitchFamily="49" charset="0"/>
-              </a:rPr>
-              <a:t>conditioning-time="0"</a:t>
-            </a:r>
-            <a:endParaRPr lang="en-DK" sz="2480" dirty="0">
-              <a:latin typeface="Courier New" panose="02070309020205020404" pitchFamily="49" charset="0"/>
-              <a:cs typeface="Courier New" panose="02070309020205020404" pitchFamily="49" charset="0"/>
-            </a:endParaRPr>
-          </a:p>
-        </p:txBody>
-      </p:sp>
-      <p:sp>
-        <p:nvSpPr>
-          <p:cNvPr id="11" name="TextBox 10">
-            <a:extLst>
-              <a:ext uri="{FF2B5EF4-FFF2-40B4-BE49-F238E27FC236}">
-                <a16:creationId xmlns:a16="http://schemas.microsoft.com/office/drawing/2014/main" id="{29C9F5F5-B0FC-A2AD-638D-50A91912505F}"/>
-              </a:ext>
-            </a:extLst>
-          </p:cNvPr>
-          <p:cNvSpPr txBox="1"/>
-          <p:nvPr/>
-        </p:nvSpPr>
-        <p:spPr>
-          <a:xfrm>
-            <a:off x="9529556" y="11960656"/>
-            <a:ext cx="8321240" cy="855619"/>
-          </a:xfrm>
-          <a:prstGeom prst="rect">
-            <a:avLst/>
-          </a:prstGeom>
-          <a:noFill/>
-        </p:spPr>
-        <p:txBody>
-          <a:bodyPr wrap="square">
-            <a:spAutoFit/>
-          </a:bodyPr>
-          <a:lstStyle/>
-          <a:p>
-            <a:pPr algn="ctr"/>
-            <a:r>
-              <a:rPr lang="en-GB" sz="2480" dirty="0">
-                <a:latin typeface="Courier New" panose="02070309020205020404" pitchFamily="49" charset="0"/>
-                <a:cs typeface="Courier New" panose="02070309020205020404" pitchFamily="49" charset="0"/>
-              </a:rPr>
-              <a:t>delta-conditional-pressure="0“</a:t>
-            </a:r>
-          </a:p>
-          <a:p>
-            <a:pPr algn="ctr"/>
-            <a:r>
-              <a:rPr lang="en-GB" sz="2480" dirty="0">
-                <a:latin typeface="Courier New" panose="02070309020205020404" pitchFamily="49" charset="0"/>
-                <a:cs typeface="Courier New" panose="02070309020205020404" pitchFamily="49" charset="0"/>
-              </a:rPr>
-              <a:t>conditioning-time="30"</a:t>
-            </a:r>
-            <a:endParaRPr lang="en-DK" sz="2480" dirty="0">
-              <a:latin typeface="Courier New" panose="02070309020205020404" pitchFamily="49" charset="0"/>
-              <a:cs typeface="Courier New" panose="02070309020205020404" pitchFamily="49" charset="0"/>
-            </a:endParaRPr>
-          </a:p>
-        </p:txBody>
-      </p:sp>
-      <p:pic>
-        <p:nvPicPr>
-          <p:cNvPr id="23" name="Picture 22">
-            <a:extLst>
-              <a:ext uri="{FF2B5EF4-FFF2-40B4-BE49-F238E27FC236}">
-                <a16:creationId xmlns:a16="http://schemas.microsoft.com/office/drawing/2014/main" id="{7D2654F7-E6E3-8D26-3020-047420F69A44}"/>
-              </a:ext>
-            </a:extLst>
-          </p:cNvPr>
-          <p:cNvPicPr>
-            <a:picLocks noChangeAspect="1"/>
-          </p:cNvPicPr>
-          <p:nvPr/>
-        </p:nvPicPr>
-        <p:blipFill>
-          <a:blip r:embed="rId3"/>
-          <a:stretch>
-            <a:fillRect/>
-          </a:stretch>
-        </p:blipFill>
-        <p:spPr>
-          <a:xfrm>
-            <a:off x="1870962" y="1794423"/>
-            <a:ext cx="7653938" cy="4630159"/>
-          </a:xfrm>
-          <a:prstGeom prst="rect">
-            <a:avLst/>
-          </a:prstGeom>
-        </p:spPr>
-      </p:pic>
-      <p:pic>
-        <p:nvPicPr>
-          <p:cNvPr id="25" name="Picture 24">
-            <a:extLst>
-              <a:ext uri="{FF2B5EF4-FFF2-40B4-BE49-F238E27FC236}">
-                <a16:creationId xmlns:a16="http://schemas.microsoft.com/office/drawing/2014/main" id="{D489A1A0-CA50-B327-A4B4-0399839613F5}"/>
-              </a:ext>
-            </a:extLst>
-          </p:cNvPr>
-          <p:cNvPicPr>
-            <a:picLocks noChangeAspect="1"/>
-          </p:cNvPicPr>
-          <p:nvPr/>
-        </p:nvPicPr>
-        <p:blipFill>
-          <a:blip r:embed="rId4"/>
-          <a:stretch>
-            <a:fillRect/>
-          </a:stretch>
-        </p:blipFill>
-        <p:spPr>
-          <a:xfrm>
-            <a:off x="1870962" y="7498011"/>
-            <a:ext cx="7653938" cy="4632647"/>
-          </a:xfrm>
-          <a:prstGeom prst="rect">
-            <a:avLst/>
-          </a:prstGeom>
-        </p:spPr>
-      </p:pic>
-      <p:pic>
-        <p:nvPicPr>
-          <p:cNvPr id="27" name="Picture 26">
-            <a:extLst>
-              <a:ext uri="{FF2B5EF4-FFF2-40B4-BE49-F238E27FC236}">
-                <a16:creationId xmlns:a16="http://schemas.microsoft.com/office/drawing/2014/main" id="{CCBD8EB3-1358-8B4F-D299-042AE387156D}"/>
-              </a:ext>
-            </a:extLst>
-          </p:cNvPr>
-          <p:cNvPicPr>
-            <a:picLocks noChangeAspect="1"/>
-          </p:cNvPicPr>
-          <p:nvPr/>
-        </p:nvPicPr>
-        <p:blipFill>
-          <a:blip r:embed="rId5"/>
-          <a:stretch>
-            <a:fillRect/>
-          </a:stretch>
-        </p:blipFill>
-        <p:spPr>
-          <a:xfrm>
-            <a:off x="10100968" y="1794423"/>
-            <a:ext cx="7653938" cy="4582914"/>
-          </a:xfrm>
-          <a:prstGeom prst="rect">
-            <a:avLst/>
-          </a:prstGeom>
-        </p:spPr>
-      </p:pic>
-      <p:pic>
-        <p:nvPicPr>
-          <p:cNvPr id="29" name="Picture 28">
-            <a:extLst>
-              <a:ext uri="{FF2B5EF4-FFF2-40B4-BE49-F238E27FC236}">
-                <a16:creationId xmlns:a16="http://schemas.microsoft.com/office/drawing/2014/main" id="{B575FE4D-1AD8-D849-2C0E-FFFD43AF901D}"/>
-              </a:ext>
-            </a:extLst>
-          </p:cNvPr>
-          <p:cNvPicPr>
-            <a:picLocks noChangeAspect="1"/>
-          </p:cNvPicPr>
-          <p:nvPr/>
-        </p:nvPicPr>
-        <p:blipFill>
-          <a:blip r:embed="rId6"/>
-          <a:stretch>
-            <a:fillRect/>
-          </a:stretch>
-        </p:blipFill>
-        <p:spPr>
-          <a:xfrm>
-            <a:off x="10100968" y="7498012"/>
-            <a:ext cx="7653938" cy="4597102"/>
-          </a:xfrm>
-          <a:prstGeom prst="rect">
-            <a:avLst/>
-          </a:prstGeom>
-        </p:spPr>
-      </p:pic>
-    </p:spTree>
-    <p:extLst>
-      <p:ext uri="{BB962C8B-B14F-4D97-AF65-F5344CB8AC3E}">
-        <p14:creationId xmlns:p14="http://schemas.microsoft.com/office/powerpoint/2010/main" val="3314536849"/>
       </p:ext>
     </p:extLst>
   </p:cSld>
@@ -13398,17 +12644,6 @@
 </file>
 
 <file path=customXml/item1.xml><?xml version="1.0" encoding="utf-8"?>
-<p:properties xmlns:p="http://schemas.microsoft.com/office/2006/metadata/properties" xmlns:xsi="http://www.w3.org/2001/XMLSchema-instance" xmlns:pc="http://schemas.microsoft.com/office/infopath/2007/PartnerControls">
-  <documentManagement>
-    <TaxCatchAll xmlns="6dfb7b4b-871d-4c24-9d42-16b14ecd044c" xsi:nil="true"/>
-    <lcf76f155ced4ddcb4097134ff3c332f xmlns="51c7d8ad-74c8-4833-8478-0d0a5cafce0c">
-      <Terms xmlns="http://schemas.microsoft.com/office/infopath/2007/PartnerControls"/>
-    </lcf76f155ced4ddcb4097134ff3c332f>
-  </documentManagement>
-</p:properties>
-</file>
-
-<file path=customXml/item2.xml><?xml version="1.0" encoding="utf-8"?>
 <ct:contentTypeSchema xmlns:ct="http://schemas.microsoft.com/office/2006/metadata/contentType" xmlns:ma="http://schemas.microsoft.com/office/2006/metadata/properties/metaAttributes" ct:_="" ma:_="" ma:contentTypeName="Document" ma:contentTypeID="0x0101005B996248A2D0E04D87B9DBB54D269DA4" ma:contentTypeVersion="18" ma:contentTypeDescription="Create a new document." ma:contentTypeScope="" ma:versionID="f22bde94a6705f7f7e236c14bc19f189">
   <xsd:schema xmlns:xsd="http://www.w3.org/2001/XMLSchema" xmlns:xs="http://www.w3.org/2001/XMLSchema" xmlns:p="http://schemas.microsoft.com/office/2006/metadata/properties" xmlns:ns2="51c7d8ad-74c8-4833-8478-0d0a5cafce0c" xmlns:ns3="6dfb7b4b-871d-4c24-9d42-16b14ecd044c" targetNamespace="http://schemas.microsoft.com/office/2006/metadata/properties" ma:root="true" ma:fieldsID="273248db29f554cba2c15e8dd349c138" ns2:_="" ns3:_="">
     <xsd:import namespace="51c7d8ad-74c8-4833-8478-0d0a5cafce0c"/>
@@ -13663,6 +12898,17 @@
 </ct:contentTypeSchema>
 </file>
 
+<file path=customXml/item2.xml><?xml version="1.0" encoding="utf-8"?>
+<p:properties xmlns:p="http://schemas.microsoft.com/office/2006/metadata/properties" xmlns:xsi="http://www.w3.org/2001/XMLSchema-instance" xmlns:pc="http://schemas.microsoft.com/office/infopath/2007/PartnerControls">
+  <documentManagement>
+    <TaxCatchAll xmlns="6dfb7b4b-871d-4c24-9d42-16b14ecd044c" xsi:nil="true"/>
+    <lcf76f155ced4ddcb4097134ff3c332f xmlns="51c7d8ad-74c8-4833-8478-0d0a5cafce0c">
+      <Terms xmlns="http://schemas.microsoft.com/office/infopath/2007/PartnerControls"/>
+    </lcf76f155ced4ddcb4097134ff3c332f>
+  </documentManagement>
+</p:properties>
+</file>
+
 <file path=customXml/item3.xml><?xml version="1.0" encoding="utf-8"?>
 <?mso-contentType ?>
 <FormTemplates xmlns="http://schemas.microsoft.com/sharepoint/v3/contenttype/forms">
@@ -13673,17 +12919,6 @@
 </file>
 
 <file path=customXml/itemProps1.xml><?xml version="1.0" encoding="utf-8"?>
-<ds:datastoreItem xmlns:ds="http://schemas.openxmlformats.org/officeDocument/2006/customXml" ds:itemID="{2EF670CE-B0AA-4D52-AFC6-AA4BF7D46EEA}">
-  <ds:schemaRefs>
-    <ds:schemaRef ds:uri="http://schemas.microsoft.com/office/2006/metadata/properties"/>
-    <ds:schemaRef ds:uri="http://schemas.microsoft.com/office/infopath/2007/PartnerControls"/>
-    <ds:schemaRef ds:uri="6dfb7b4b-871d-4c24-9d42-16b14ecd044c"/>
-    <ds:schemaRef ds:uri="51c7d8ad-74c8-4833-8478-0d0a5cafce0c"/>
-  </ds:schemaRefs>
-</ds:datastoreItem>
-</file>
-
-<file path=customXml/itemProps2.xml><?xml version="1.0" encoding="utf-8"?>
 <ds:datastoreItem xmlns:ds="http://schemas.openxmlformats.org/officeDocument/2006/customXml" ds:itemID="{172A1115-3E72-42E2-A544-7EAA53D3702E}">
   <ds:schemaRefs>
     <ds:schemaRef ds:uri="http://schemas.microsoft.com/office/2006/metadata/contentType"/>
@@ -13702,6 +12937,17 @@
 </ds:datastoreItem>
 </file>
 
+<file path=customXml/itemProps2.xml><?xml version="1.0" encoding="utf-8"?>
+<ds:datastoreItem xmlns:ds="http://schemas.openxmlformats.org/officeDocument/2006/customXml" ds:itemID="{2EF670CE-B0AA-4D52-AFC6-AA4BF7D46EEA}">
+  <ds:schemaRefs>
+    <ds:schemaRef ds:uri="http://schemas.microsoft.com/office/2006/metadata/properties"/>
+    <ds:schemaRef ds:uri="http://schemas.microsoft.com/office/infopath/2007/PartnerControls"/>
+    <ds:schemaRef ds:uri="6dfb7b4b-871d-4c24-9d42-16b14ecd044c"/>
+    <ds:schemaRef ds:uri="51c7d8ad-74c8-4833-8478-0d0a5cafce0c"/>
+  </ds:schemaRefs>
+</ds:datastoreItem>
+</file>
+
 <file path=customXml/itemProps3.xml><?xml version="1.0" encoding="utf-8"?>
 <ds:datastoreItem xmlns:ds="http://schemas.openxmlformats.org/officeDocument/2006/customXml" ds:itemID="{EF875D47-8106-485E-98E0-D60C6A98DA6A}">
   <ds:schemaRefs>

</xml_diff>